<commit_message>
Simpler version with wavelength spectrum
</commit_message>
<xml_diff>
--- a/WhyIsSkyBlue.pptx
+++ b/WhyIsSkyBlue.pptx
@@ -9,10 +9,9 @@
     <p:sldId id="257" r:id="rId3"/>
     <p:sldId id="258" r:id="rId4"/>
     <p:sldId id="259" r:id="rId5"/>
-    <p:sldId id="260" r:id="rId6"/>
   </p:sldIdLst>
   <p:notesMasterIdLst>
-    <p:notesMasterId r:id="rId7"/>
+    <p:notesMasterId r:id="rId6"/>
   </p:notesMasterIdLst>
   <p:sldSz cx="9144000" cy="5143500"/>
   <p:notesSz cx="5143500" cy="9144000"/>
@@ -812,94 +811,6 @@
 </p:notes>
 </file>
 
-<file path=ppt/notesSlides/notesSlide5.xml><?xml version="1.0" encoding="utf-8"?>
-<p:notes xmlns:a="http://schemas.openxmlformats.org/drawingml/2006/main" xmlns:r="http://schemas.openxmlformats.org/officeDocument/2006/relationships" xmlns:p="http://schemas.openxmlformats.org/presentationml/2006/main">
-  <p:cSld>
-    <p:spTree>
-      <p:nvGrpSpPr>
-        <p:cNvPr id="1" name=""/>
-        <p:cNvGrpSpPr/>
-        <p:nvPr/>
-      </p:nvGrpSpPr>
-      <p:grpSpPr>
-        <a:xfrm>
-          <a:off x="0" y="0"/>
-          <a:ext cx="0" cy="0"/>
-          <a:chOff x="0" y="0"/>
-          <a:chExt cx="0" cy="0"/>
-        </a:xfrm>
-      </p:grpSpPr>
-      <p:sp>
-        <p:nvSpPr>
-          <p:cNvPr id="2" name="Slide Image Placeholder 1"/>
-          <p:cNvSpPr>
-            <a:spLocks noGrp="1" noRot="1" noChangeAspect="1"/>
-          </p:cNvSpPr>
-          <p:nvPr>
-            <p:ph type="sldImg"/>
-          </p:nvPr>
-        </p:nvSpPr>
-        <p:spPr/>
-      </p:sp>
-      <p:sp>
-        <p:nvSpPr>
-          <p:cNvPr id="3" name="Notes Placeholder 2"/>
-          <p:cNvSpPr>
-            <a:spLocks noGrp="1"/>
-          </p:cNvSpPr>
-          <p:nvPr>
-            <p:ph type="body" idx="1"/>
-          </p:nvPr>
-        </p:nvSpPr>
-        <p:spPr/>
-        <p:txBody>
-          <a:bodyPr/>
-          <a:lstStyle/>
-          <a:p>
-            <a:r>
-              <a:rPr lang="en-US" dirty="0"/>
-              <a:t/>
-            </a:r>
-            <a:endParaRPr lang="en-US" dirty="0"/>
-          </a:p>
-        </p:txBody>
-      </p:sp>
-      <p:sp>
-        <p:nvSpPr>
-          <p:cNvPr id="4" name="Slide Number Placeholder 3"/>
-          <p:cNvSpPr>
-            <a:spLocks noGrp="1"/>
-          </p:cNvSpPr>
-          <p:nvPr>
-            <p:ph type="sldNum" sz="quarter" idx="10"/>
-          </p:nvPr>
-        </p:nvSpPr>
-        <p:spPr/>
-        <p:txBody>
-          <a:bodyPr/>
-          <a:lstStyle/>
-          <a:p>
-            <a:fld id="{F7021451-1387-4CA6-816F-3879F97B5CBC}" type="slidenum">
-              <a:rPr lang="en-US"/>
-              <a:t>5</a:t>
-            </a:fld>
-            <a:endParaRPr lang="en-US"/>
-          </a:p>
-        </p:txBody>
-      </p:sp>
-    </p:spTree>
-    <p:extLst>
-      <p:ext uri="{BB962C8B-B14F-4D97-AF65-F5344CB8AC3E}">
-        <p14:creationId xmlns:p14="http://schemas.microsoft.com/office/powerpoint/2010/main" val="1024086991"/>
-      </p:ext>
-    </p:extLst>
-  </p:cSld>
-  <p:clrMapOvr>
-    <a:masterClrMapping/>
-  </p:clrMapOvr>
-</p:notes>
-</file>
-
 <file path=ppt/slideLayouts/slideLayout1.xml><?xml version="1.0" encoding="utf-8"?>
 <p:sldLayout xmlns:a="http://schemas.openxmlformats.org/drawingml/2006/main" xmlns:r="http://schemas.openxmlformats.org/officeDocument/2006/relationships" xmlns:p="http://schemas.openxmlformats.org/presentationml/2006/main" preserve="1">
   <p:cSld name="DEFAULT">
@@ -1239,7 +1150,7 @@
         </p:nvSpPr>
         <p:spPr>
           <a:xfrm>
-            <a:off x="6583680" y="-914400"/>
+            <a:off x="6858000" y="-1097280"/>
             <a:ext cx="4114800" cy="4114800"/>
           </a:xfrm>
           <a:prstGeom prst="ellipse">
@@ -1264,8 +1175,8 @@
         </p:nvSpPr>
         <p:spPr>
           <a:xfrm>
-            <a:off x="457200" y="914400"/>
-            <a:ext cx="6400800" cy="731520"/>
+            <a:off x="457200" y="1463040"/>
+            <a:ext cx="6400800" cy="1371600"/>
           </a:xfrm>
           <a:prstGeom prst="rect">
             <a:avLst/>
@@ -1281,112 +1192,56 @@
               <a:buNone/>
             </a:pPr>
             <a:r>
-              <a:rPr lang="en-US" sz="3200" dirty="0">
+              <a:rPr lang="en-US" sz="5200" b="1" dirty="0">
                 <a:solidFill>
                   <a:srgbClr val="FFFFFF"/>
+                </a:solidFill>
+                <a:latin typeface="Georgia" pitchFamily="34" charset="0"/>
+                <a:ea typeface="Georgia" pitchFamily="34" charset="-122"/>
+                <a:cs typeface="Georgia" pitchFamily="34" charset="-120"/>
+              </a:rPr>
+              <a:t>Why is the sky blue?</a:t>
+            </a:r>
+            <a:endParaRPr lang="en-US" sz="5200" dirty="0"/>
+          </a:p>
+        </p:txBody>
+      </p:sp>
+      <p:sp>
+        <p:nvSpPr>
+          <p:cNvPr id="4" name="Text 2"/>
+          <p:cNvSpPr/>
+          <p:nvPr/>
+        </p:nvSpPr>
+        <p:spPr>
+          <a:xfrm>
+            <a:off x="457200" y="3017520"/>
+            <a:ext cx="5486400" cy="548640"/>
+          </a:xfrm>
+          <a:prstGeom prst="rect">
+            <a:avLst/>
+          </a:prstGeom>
+          <a:noFill/>
+          <a:ln/>
+        </p:spPr>
+        <p:txBody>
+          <a:bodyPr wrap="square" lIns="0" tIns="0" rIns="0" bIns="0" rtlCol="0" anchor="ctr"/>
+          <a:lstStyle/>
+          <a:p>
+            <a:pPr indent="0" marL="0">
+              <a:buNone/>
+            </a:pPr>
+            <a:r>
+              <a:rPr lang="en-US" sz="2000" i="1" dirty="0">
+                <a:solidFill>
+                  <a:srgbClr val="F5C842"/>
                 </a:solidFill>
                 <a:latin typeface="Calibri" pitchFamily="34" charset="0"/>
                 <a:ea typeface="Calibri" pitchFamily="34" charset="-122"/>
                 <a:cs typeface="Calibri" pitchFamily="34" charset="-120"/>
               </a:rPr>
-              <a:t>Why is the</a:t>
-            </a:r>
-            <a:endParaRPr lang="en-US" sz="3200" dirty="0"/>
-          </a:p>
-        </p:txBody>
-      </p:sp>
-      <p:sp>
-        <p:nvSpPr>
-          <p:cNvPr id="4" name="Text 2"/>
-          <p:cNvSpPr/>
-          <p:nvPr/>
-        </p:nvSpPr>
-        <p:spPr>
-          <a:xfrm>
-            <a:off x="457200" y="1600200"/>
-            <a:ext cx="6400800" cy="1188720"/>
-          </a:xfrm>
-          <a:prstGeom prst="rect">
-            <a:avLst/>
-          </a:prstGeom>
-          <a:noFill/>
-          <a:ln/>
-        </p:spPr>
-        <p:txBody>
-          <a:bodyPr wrap="square" lIns="0" tIns="0" rIns="0" bIns="0" rtlCol="0" anchor="ctr"/>
-          <a:lstStyle/>
-          <a:p>
-            <a:pPr indent="0" marL="0">
-              <a:buNone/>
-            </a:pPr>
-            <a:r>
-              <a:rPr lang="en-US" sz="6400" b="1" dirty="0">
-                <a:solidFill>
-                  <a:srgbClr val="F5C842"/>
-                </a:solidFill>
-                <a:latin typeface="Georgia" pitchFamily="34" charset="0"/>
-                <a:ea typeface="Georgia" pitchFamily="34" charset="-122"/>
-                <a:cs typeface="Georgia" pitchFamily="34" charset="-120"/>
-              </a:rPr>
-              <a:t>Sky Blue?</a:t>
-            </a:r>
-            <a:endParaRPr lang="en-US" sz="6400" dirty="0"/>
-          </a:p>
-        </p:txBody>
-      </p:sp>
-      <p:sp>
-        <p:nvSpPr>
-          <p:cNvPr id="5" name="Text 3"/>
-          <p:cNvSpPr/>
-          <p:nvPr/>
-        </p:nvSpPr>
-        <p:spPr>
-          <a:xfrm>
-            <a:off x="457200" y="2926080"/>
-            <a:ext cx="5943600" cy="822960"/>
-          </a:xfrm>
-          <a:prstGeom prst="rect">
-            <a:avLst/>
-          </a:prstGeom>
-          <a:noFill/>
-          <a:ln/>
-        </p:spPr>
-        <p:txBody>
-          <a:bodyPr wrap="square" lIns="0" tIns="0" rIns="0" bIns="0" rtlCol="0" anchor="ctr"/>
-          <a:lstStyle/>
-          <a:p>
-            <a:pPr indent="0" marL="0">
-              <a:buNone/>
-            </a:pPr>
-            <a:r>
-              <a:rPr lang="en-US" sz="1600" i="1" dirty="0">
-                <a:solidFill>
-                  <a:srgbClr val="FFFFFF"/>
-                </a:solidFill>
-                <a:latin typeface="Calibri" pitchFamily="34" charset="0"/>
-                <a:ea typeface="Calibri" pitchFamily="34" charset="-122"/>
-                <a:cs typeface="Calibri" pitchFamily="34" charset="-120"/>
-              </a:rPr>
-              <a:t>A 2-minute answer to a question</a:t>
-            </a:r>
-            <a:endParaRPr lang="en-US" sz="1600" dirty="0"/>
-          </a:p>
-          <a:p>
-            <a:pPr indent="0" marL="0">
-              <a:buNone/>
-            </a:pPr>
-            <a:r>
-              <a:rPr lang="en-US" sz="1600" i="1" dirty="0">
-                <a:solidFill>
-                  <a:srgbClr val="FFFFFF"/>
-                </a:solidFill>
-                <a:latin typeface="Calibri" pitchFamily="34" charset="0"/>
-                <a:ea typeface="Calibri" pitchFamily="34" charset="-122"/>
-                <a:cs typeface="Calibri" pitchFamily="34" charset="-120"/>
-              </a:rPr>
-              <a:t>you've wondered about your whole life.</a:t>
-            </a:r>
-            <a:endParaRPr lang="en-US" sz="1600" dirty="0"/>
+              <a:t>A simple 2-minute explanation.</a:t>
+            </a:r>
+            <a:endParaRPr lang="en-US" sz="2000" dirty="0"/>
           </a:p>
         </p:txBody>
       </p:sp>
@@ -1430,8 +1285,8 @@
         </p:nvSpPr>
         <p:spPr>
           <a:xfrm>
-            <a:off x="457200" y="274320"/>
-            <a:ext cx="8229600" cy="731520"/>
+            <a:off x="457200" y="228600"/>
+            <a:ext cx="8229600" cy="640080"/>
           </a:xfrm>
           <a:prstGeom prst="rect">
             <a:avLst/>
@@ -1447,7 +1302,7 @@
               <a:buNone/>
             </a:pPr>
             <a:r>
-              <a:rPr lang="en-US" sz="3600" b="1" dirty="0">
+              <a:rPr lang="en-US" sz="2800" b="1" dirty="0">
                 <a:solidFill>
                   <a:srgbClr val="0D3B6E"/>
                 </a:solidFill>
@@ -1455,9 +1310,9 @@
                 <a:ea typeface="Georgia" pitchFamily="34" charset="-122"/>
                 <a:cs typeface="Georgia" pitchFamily="34" charset="-120"/>
               </a:rPr>
-              <a:t>Sunlight isn't just white</a:t>
-            </a:r>
-            <a:endParaRPr lang="en-US" sz="3600" dirty="0"/>
+              <a:t>Light comes in different wavelengths</a:t>
+            </a:r>
+            <a:endParaRPr lang="en-US" sz="2800" dirty="0"/>
           </a:p>
         </p:txBody>
       </p:sp>
@@ -1469,8 +1324,8 @@
         </p:nvSpPr>
         <p:spPr>
           <a:xfrm>
-            <a:off x="457200" y="1005840"/>
-            <a:ext cx="8229600" cy="457200"/>
+            <a:off x="457200" y="749808"/>
+            <a:ext cx="8229600" cy="347472"/>
           </a:xfrm>
           <a:prstGeom prst="rect">
             <a:avLst/>
@@ -1486,17 +1341,17 @@
               <a:buNone/>
             </a:pPr>
             <a:r>
-              <a:rPr lang="en-US" sz="1800" dirty="0">
-                <a:solidFill>
-                  <a:srgbClr val="555555"/>
+              <a:rPr lang="en-US" sz="1400" dirty="0">
+                <a:solidFill>
+                  <a:srgbClr val="444444"/>
                 </a:solidFill>
                 <a:latin typeface="Calibri" pitchFamily="34" charset="0"/>
                 <a:ea typeface="Calibri" pitchFamily="34" charset="-122"/>
                 <a:cs typeface="Calibri" pitchFamily="34" charset="-120"/>
               </a:rPr>
-              <a:t>It's actually a mix of ALL colors of the rainbow.</a:t>
-            </a:r>
-            <a:endParaRPr lang="en-US" sz="1800" dirty="0"/>
+              <a:t>Each color = a different wavelength, measured in nanometres (nm).</a:t>
+            </a:r>
+            <a:endParaRPr lang="en-US" sz="1400" dirty="0"/>
           </a:p>
         </p:txBody>
       </p:sp>
@@ -1508,18 +1363,18 @@
         </p:nvSpPr>
         <p:spPr>
           <a:xfrm>
-            <a:off x="457200" y="1691640"/>
-            <a:ext cx="1051560" cy="2011680"/>
-          </a:xfrm>
-          <a:prstGeom prst="rect">
-            <a:avLst/>
-          </a:prstGeom>
-          <a:solidFill>
-            <a:srgbClr val="E63946"/>
+            <a:off x="365760" y="1234440"/>
+            <a:ext cx="1402080" cy="1645920"/>
+          </a:xfrm>
+          <a:prstGeom prst="rect">
+            <a:avLst/>
+          </a:prstGeom>
+          <a:solidFill>
+            <a:srgbClr val="7B00D4"/>
           </a:solidFill>
           <a:ln w="12700">
             <a:solidFill>
-              <a:srgbClr val="E63946"/>
+              <a:srgbClr val="7B00D4"/>
             </a:solidFill>
             <a:prstDash val="solid"/>
           </a:ln>
@@ -1533,8 +1388,8 @@
         </p:nvSpPr>
         <p:spPr>
           <a:xfrm>
-            <a:off x="457200" y="3749040"/>
-            <a:ext cx="1051560" cy="365760"/>
+            <a:off x="365760" y="2953512"/>
+            <a:ext cx="1402080" cy="320040"/>
           </a:xfrm>
           <a:prstGeom prst="rect">
             <a:avLst/>
@@ -1550,40 +1405,79 @@
               <a:buNone/>
             </a:pPr>
             <a:r>
-              <a:rPr lang="en-US" sz="1200" dirty="0">
-                <a:solidFill>
-                  <a:srgbClr val="555555"/>
+              <a:rPr lang="en-US" sz="1300" b="1" dirty="0">
+                <a:solidFill>
+                  <a:srgbClr val="0D3B6E"/>
                 </a:solidFill>
                 <a:latin typeface="Calibri" pitchFamily="34" charset="0"/>
                 <a:ea typeface="Calibri" pitchFamily="34" charset="-122"/>
                 <a:cs typeface="Calibri" pitchFamily="34" charset="-120"/>
               </a:rPr>
-              <a:t>Red</a:t>
-            </a:r>
-            <a:endParaRPr lang="en-US" sz="1200" dirty="0"/>
-          </a:p>
-        </p:txBody>
-      </p:sp>
-      <p:sp>
-        <p:nvSpPr>
-          <p:cNvPr id="6" name="Shape 4"/>
-          <p:cNvSpPr/>
-          <p:nvPr/>
-        </p:nvSpPr>
-        <p:spPr>
-          <a:xfrm>
-            <a:off x="1618488" y="1691640"/>
-            <a:ext cx="1051560" cy="2011680"/>
-          </a:xfrm>
-          <a:prstGeom prst="rect">
-            <a:avLst/>
-          </a:prstGeom>
-          <a:solidFill>
-            <a:srgbClr val="F4A261"/>
+              <a:t>Violet</a:t>
+            </a:r>
+            <a:endParaRPr lang="en-US" sz="1300" dirty="0"/>
+          </a:p>
+        </p:txBody>
+      </p:sp>
+      <p:sp>
+        <p:nvSpPr>
+          <p:cNvPr id="6" name="Text 4"/>
+          <p:cNvSpPr/>
+          <p:nvPr/>
+        </p:nvSpPr>
+        <p:spPr>
+          <a:xfrm>
+            <a:off x="365760" y="3264408"/>
+            <a:ext cx="1402080" cy="274320"/>
+          </a:xfrm>
+          <a:prstGeom prst="rect">
+            <a:avLst/>
+          </a:prstGeom>
+          <a:noFill/>
+          <a:ln/>
+        </p:spPr>
+        <p:txBody>
+          <a:bodyPr wrap="square" lIns="0" tIns="0" rIns="0" bIns="0" rtlCol="0" anchor="ctr"/>
+          <a:lstStyle/>
+          <a:p>
+            <a:pPr algn="ctr" indent="0" marL="0">
+              <a:buNone/>
+            </a:pPr>
+            <a:r>
+              <a:rPr lang="en-US" sz="1100" dirty="0">
+                <a:solidFill>
+                  <a:srgbClr val="444444"/>
+                </a:solidFill>
+                <a:latin typeface="Calibri" pitchFamily="34" charset="0"/>
+                <a:ea typeface="Calibri" pitchFamily="34" charset="-122"/>
+                <a:cs typeface="Calibri" pitchFamily="34" charset="-120"/>
+              </a:rPr>
+              <a:t>380–450 nm</a:t>
+            </a:r>
+            <a:endParaRPr lang="en-US" sz="1100" dirty="0"/>
+          </a:p>
+        </p:txBody>
+      </p:sp>
+      <p:sp>
+        <p:nvSpPr>
+          <p:cNvPr id="7" name="Shape 5"/>
+          <p:cNvSpPr/>
+          <p:nvPr/>
+        </p:nvSpPr>
+        <p:spPr>
+          <a:xfrm>
+            <a:off x="1767840" y="1234440"/>
+            <a:ext cx="1402080" cy="1645920"/>
+          </a:xfrm>
+          <a:prstGeom prst="rect">
+            <a:avLst/>
+          </a:prstGeom>
+          <a:solidFill>
+            <a:srgbClr val="3B4FE0"/>
           </a:solidFill>
           <a:ln w="12700">
             <a:solidFill>
-              <a:srgbClr val="F4A261"/>
+              <a:srgbClr val="3B4FE0"/>
             </a:solidFill>
             <a:prstDash val="solid"/>
           </a:ln>
@@ -1591,14 +1485,14 @@
       </p:sp>
       <p:sp>
         <p:nvSpPr>
-          <p:cNvPr id="7" name="Text 5"/>
-          <p:cNvSpPr/>
-          <p:nvPr/>
-        </p:nvSpPr>
-        <p:spPr>
-          <a:xfrm>
-            <a:off x="1618488" y="3749040"/>
-            <a:ext cx="1051560" cy="365760"/>
+          <p:cNvPr id="8" name="Text 6"/>
+          <p:cNvSpPr/>
+          <p:nvPr/>
+        </p:nvSpPr>
+        <p:spPr>
+          <a:xfrm>
+            <a:off x="1767840" y="2953512"/>
+            <a:ext cx="1402080" cy="320040"/>
           </a:xfrm>
           <a:prstGeom prst="rect">
             <a:avLst/>
@@ -1614,40 +1508,79 @@
               <a:buNone/>
             </a:pPr>
             <a:r>
-              <a:rPr lang="en-US" sz="1200" dirty="0">
-                <a:solidFill>
-                  <a:srgbClr val="555555"/>
+              <a:rPr lang="en-US" sz="1300" b="1" dirty="0">
+                <a:solidFill>
+                  <a:srgbClr val="0D3B6E"/>
                 </a:solidFill>
                 <a:latin typeface="Calibri" pitchFamily="34" charset="0"/>
                 <a:ea typeface="Calibri" pitchFamily="34" charset="-122"/>
                 <a:cs typeface="Calibri" pitchFamily="34" charset="-120"/>
               </a:rPr>
-              <a:t>Orange</a:t>
-            </a:r>
-            <a:endParaRPr lang="en-US" sz="1200" dirty="0"/>
-          </a:p>
-        </p:txBody>
-      </p:sp>
-      <p:sp>
-        <p:nvSpPr>
-          <p:cNvPr id="8" name="Shape 6"/>
-          <p:cNvSpPr/>
-          <p:nvPr/>
-        </p:nvSpPr>
-        <p:spPr>
-          <a:xfrm>
-            <a:off x="2779776" y="1691640"/>
-            <a:ext cx="1051560" cy="2011680"/>
-          </a:xfrm>
-          <a:prstGeom prst="rect">
-            <a:avLst/>
-          </a:prstGeom>
-          <a:solidFill>
-            <a:srgbClr val="E9C46A"/>
+              <a:t>Blue</a:t>
+            </a:r>
+            <a:endParaRPr lang="en-US" sz="1300" dirty="0"/>
+          </a:p>
+        </p:txBody>
+      </p:sp>
+      <p:sp>
+        <p:nvSpPr>
+          <p:cNvPr id="9" name="Text 7"/>
+          <p:cNvSpPr/>
+          <p:nvPr/>
+        </p:nvSpPr>
+        <p:spPr>
+          <a:xfrm>
+            <a:off x="1767840" y="3264408"/>
+            <a:ext cx="1402080" cy="274320"/>
+          </a:xfrm>
+          <a:prstGeom prst="rect">
+            <a:avLst/>
+          </a:prstGeom>
+          <a:noFill/>
+          <a:ln/>
+        </p:spPr>
+        <p:txBody>
+          <a:bodyPr wrap="square" lIns="0" tIns="0" rIns="0" bIns="0" rtlCol="0" anchor="ctr"/>
+          <a:lstStyle/>
+          <a:p>
+            <a:pPr algn="ctr" indent="0" marL="0">
+              <a:buNone/>
+            </a:pPr>
+            <a:r>
+              <a:rPr lang="en-US" sz="1100" dirty="0">
+                <a:solidFill>
+                  <a:srgbClr val="444444"/>
+                </a:solidFill>
+                <a:latin typeface="Calibri" pitchFamily="34" charset="0"/>
+                <a:ea typeface="Calibri" pitchFamily="34" charset="-122"/>
+                <a:cs typeface="Calibri" pitchFamily="34" charset="-120"/>
+              </a:rPr>
+              <a:t>450–495 nm</a:t>
+            </a:r>
+            <a:endParaRPr lang="en-US" sz="1100" dirty="0"/>
+          </a:p>
+        </p:txBody>
+      </p:sp>
+      <p:sp>
+        <p:nvSpPr>
+          <p:cNvPr id="10" name="Shape 8"/>
+          <p:cNvSpPr/>
+          <p:nvPr/>
+        </p:nvSpPr>
+        <p:spPr>
+          <a:xfrm>
+            <a:off x="3169920" y="1234440"/>
+            <a:ext cx="1402080" cy="1645920"/>
+          </a:xfrm>
+          <a:prstGeom prst="rect">
+            <a:avLst/>
+          </a:prstGeom>
+          <a:solidFill>
+            <a:srgbClr val="1AAF5D"/>
           </a:solidFill>
           <a:ln w="12700">
             <a:solidFill>
-              <a:srgbClr val="E9C46A"/>
+              <a:srgbClr val="1AAF5D"/>
             </a:solidFill>
             <a:prstDash val="solid"/>
           </a:ln>
@@ -1655,14 +1588,14 @@
       </p:sp>
       <p:sp>
         <p:nvSpPr>
-          <p:cNvPr id="9" name="Text 7"/>
-          <p:cNvSpPr/>
-          <p:nvPr/>
-        </p:nvSpPr>
-        <p:spPr>
-          <a:xfrm>
-            <a:off x="2779776" y="3749040"/>
-            <a:ext cx="1051560" cy="365760"/>
+          <p:cNvPr id="11" name="Text 9"/>
+          <p:cNvSpPr/>
+          <p:nvPr/>
+        </p:nvSpPr>
+        <p:spPr>
+          <a:xfrm>
+            <a:off x="3169920" y="2953512"/>
+            <a:ext cx="1402080" cy="320040"/>
           </a:xfrm>
           <a:prstGeom prst="rect">
             <a:avLst/>
@@ -1678,40 +1611,79 @@
               <a:buNone/>
             </a:pPr>
             <a:r>
-              <a:rPr lang="en-US" sz="1200" dirty="0">
-                <a:solidFill>
-                  <a:srgbClr val="555555"/>
+              <a:rPr lang="en-US" sz="1300" b="1" dirty="0">
+                <a:solidFill>
+                  <a:srgbClr val="0D3B6E"/>
                 </a:solidFill>
                 <a:latin typeface="Calibri" pitchFamily="34" charset="0"/>
                 <a:ea typeface="Calibri" pitchFamily="34" charset="-122"/>
                 <a:cs typeface="Calibri" pitchFamily="34" charset="-120"/>
               </a:rPr>
-              <a:t>Yellow</a:t>
-            </a:r>
-            <a:endParaRPr lang="en-US" sz="1200" dirty="0"/>
-          </a:p>
-        </p:txBody>
-      </p:sp>
-      <p:sp>
-        <p:nvSpPr>
-          <p:cNvPr id="10" name="Shape 8"/>
-          <p:cNvSpPr/>
-          <p:nvPr/>
-        </p:nvSpPr>
-        <p:spPr>
-          <a:xfrm>
-            <a:off x="3941064" y="1691640"/>
-            <a:ext cx="1051560" cy="2011680"/>
-          </a:xfrm>
-          <a:prstGeom prst="rect">
-            <a:avLst/>
-          </a:prstGeom>
-          <a:solidFill>
-            <a:srgbClr val="2A9D8F"/>
+              <a:t>Green</a:t>
+            </a:r>
+            <a:endParaRPr lang="en-US" sz="1300" dirty="0"/>
+          </a:p>
+        </p:txBody>
+      </p:sp>
+      <p:sp>
+        <p:nvSpPr>
+          <p:cNvPr id="12" name="Text 10"/>
+          <p:cNvSpPr/>
+          <p:nvPr/>
+        </p:nvSpPr>
+        <p:spPr>
+          <a:xfrm>
+            <a:off x="3169920" y="3264408"/>
+            <a:ext cx="1402080" cy="274320"/>
+          </a:xfrm>
+          <a:prstGeom prst="rect">
+            <a:avLst/>
+          </a:prstGeom>
+          <a:noFill/>
+          <a:ln/>
+        </p:spPr>
+        <p:txBody>
+          <a:bodyPr wrap="square" lIns="0" tIns="0" rIns="0" bIns="0" rtlCol="0" anchor="ctr"/>
+          <a:lstStyle/>
+          <a:p>
+            <a:pPr algn="ctr" indent="0" marL="0">
+              <a:buNone/>
+            </a:pPr>
+            <a:r>
+              <a:rPr lang="en-US" sz="1100" dirty="0">
+                <a:solidFill>
+                  <a:srgbClr val="444444"/>
+                </a:solidFill>
+                <a:latin typeface="Calibri" pitchFamily="34" charset="0"/>
+                <a:ea typeface="Calibri" pitchFamily="34" charset="-122"/>
+                <a:cs typeface="Calibri" pitchFamily="34" charset="-120"/>
+              </a:rPr>
+              <a:t>495–570 nm</a:t>
+            </a:r>
+            <a:endParaRPr lang="en-US" sz="1100" dirty="0"/>
+          </a:p>
+        </p:txBody>
+      </p:sp>
+      <p:sp>
+        <p:nvSpPr>
+          <p:cNvPr id="13" name="Shape 11"/>
+          <p:cNvSpPr/>
+          <p:nvPr/>
+        </p:nvSpPr>
+        <p:spPr>
+          <a:xfrm>
+            <a:off x="4572000" y="1234440"/>
+            <a:ext cx="1402080" cy="1645920"/>
+          </a:xfrm>
+          <a:prstGeom prst="rect">
+            <a:avLst/>
+          </a:prstGeom>
+          <a:solidFill>
+            <a:srgbClr val="F5D800"/>
           </a:solidFill>
           <a:ln w="12700">
             <a:solidFill>
-              <a:srgbClr val="2A9D8F"/>
+              <a:srgbClr val="F5D800"/>
             </a:solidFill>
             <a:prstDash val="solid"/>
           </a:ln>
@@ -1719,14 +1691,14 @@
       </p:sp>
       <p:sp>
         <p:nvSpPr>
-          <p:cNvPr id="11" name="Text 9"/>
-          <p:cNvSpPr/>
-          <p:nvPr/>
-        </p:nvSpPr>
-        <p:spPr>
-          <a:xfrm>
-            <a:off x="3941064" y="3749040"/>
-            <a:ext cx="1051560" cy="365760"/>
+          <p:cNvPr id="14" name="Text 12"/>
+          <p:cNvSpPr/>
+          <p:nvPr/>
+        </p:nvSpPr>
+        <p:spPr>
+          <a:xfrm>
+            <a:off x="4572000" y="2953512"/>
+            <a:ext cx="1402080" cy="320040"/>
           </a:xfrm>
           <a:prstGeom prst="rect">
             <a:avLst/>
@@ -1742,40 +1714,79 @@
               <a:buNone/>
             </a:pPr>
             <a:r>
-              <a:rPr lang="en-US" sz="1200" dirty="0">
-                <a:solidFill>
-                  <a:srgbClr val="555555"/>
+              <a:rPr lang="en-US" sz="1300" b="1" dirty="0">
+                <a:solidFill>
+                  <a:srgbClr val="0D3B6E"/>
                 </a:solidFill>
                 <a:latin typeface="Calibri" pitchFamily="34" charset="0"/>
                 <a:ea typeface="Calibri" pitchFamily="34" charset="-122"/>
                 <a:cs typeface="Calibri" pitchFamily="34" charset="-120"/>
               </a:rPr>
-              <a:t>Green</a:t>
-            </a:r>
-            <a:endParaRPr lang="en-US" sz="1200" dirty="0"/>
-          </a:p>
-        </p:txBody>
-      </p:sp>
-      <p:sp>
-        <p:nvSpPr>
-          <p:cNvPr id="12" name="Shape 10"/>
-          <p:cNvSpPr/>
-          <p:nvPr/>
-        </p:nvSpPr>
-        <p:spPr>
-          <a:xfrm>
-            <a:off x="5102352" y="1691640"/>
-            <a:ext cx="1051560" cy="2011680"/>
-          </a:xfrm>
-          <a:prstGeom prst="rect">
-            <a:avLst/>
-          </a:prstGeom>
-          <a:solidFill>
-            <a:srgbClr val="457B9D"/>
+              <a:t>Yellow</a:t>
+            </a:r>
+            <a:endParaRPr lang="en-US" sz="1300" dirty="0"/>
+          </a:p>
+        </p:txBody>
+      </p:sp>
+      <p:sp>
+        <p:nvSpPr>
+          <p:cNvPr id="15" name="Text 13"/>
+          <p:cNvSpPr/>
+          <p:nvPr/>
+        </p:nvSpPr>
+        <p:spPr>
+          <a:xfrm>
+            <a:off x="4572000" y="3264408"/>
+            <a:ext cx="1402080" cy="274320"/>
+          </a:xfrm>
+          <a:prstGeom prst="rect">
+            <a:avLst/>
+          </a:prstGeom>
+          <a:noFill/>
+          <a:ln/>
+        </p:spPr>
+        <p:txBody>
+          <a:bodyPr wrap="square" lIns="0" tIns="0" rIns="0" bIns="0" rtlCol="0" anchor="ctr"/>
+          <a:lstStyle/>
+          <a:p>
+            <a:pPr algn="ctr" indent="0" marL="0">
+              <a:buNone/>
+            </a:pPr>
+            <a:r>
+              <a:rPr lang="en-US" sz="1100" dirty="0">
+                <a:solidFill>
+                  <a:srgbClr val="444444"/>
+                </a:solidFill>
+                <a:latin typeface="Calibri" pitchFamily="34" charset="0"/>
+                <a:ea typeface="Calibri" pitchFamily="34" charset="-122"/>
+                <a:cs typeface="Calibri" pitchFamily="34" charset="-120"/>
+              </a:rPr>
+              <a:t>570–590 nm</a:t>
+            </a:r>
+            <a:endParaRPr lang="en-US" sz="1100" dirty="0"/>
+          </a:p>
+        </p:txBody>
+      </p:sp>
+      <p:sp>
+        <p:nvSpPr>
+          <p:cNvPr id="16" name="Shape 14"/>
+          <p:cNvSpPr/>
+          <p:nvPr/>
+        </p:nvSpPr>
+        <p:spPr>
+          <a:xfrm>
+            <a:off x="5974080" y="1234440"/>
+            <a:ext cx="1402080" cy="1645920"/>
+          </a:xfrm>
+          <a:prstGeom prst="rect">
+            <a:avLst/>
+          </a:prstGeom>
+          <a:solidFill>
+            <a:srgbClr val="FF8C00"/>
           </a:solidFill>
           <a:ln w="12700">
             <a:solidFill>
-              <a:srgbClr val="457B9D"/>
+              <a:srgbClr val="FF8C00"/>
             </a:solidFill>
             <a:prstDash val="solid"/>
           </a:ln>
@@ -1783,14 +1794,14 @@
       </p:sp>
       <p:sp>
         <p:nvSpPr>
-          <p:cNvPr id="13" name="Text 11"/>
-          <p:cNvSpPr/>
-          <p:nvPr/>
-        </p:nvSpPr>
-        <p:spPr>
-          <a:xfrm>
-            <a:off x="5102352" y="3749040"/>
-            <a:ext cx="1051560" cy="365760"/>
+          <p:cNvPr id="17" name="Text 15"/>
+          <p:cNvSpPr/>
+          <p:nvPr/>
+        </p:nvSpPr>
+        <p:spPr>
+          <a:xfrm>
+            <a:off x="5974080" y="2953512"/>
+            <a:ext cx="1402080" cy="320040"/>
           </a:xfrm>
           <a:prstGeom prst="rect">
             <a:avLst/>
@@ -1806,40 +1817,79 @@
               <a:buNone/>
             </a:pPr>
             <a:r>
-              <a:rPr lang="en-US" sz="1200" dirty="0">
-                <a:solidFill>
-                  <a:srgbClr val="555555"/>
+              <a:rPr lang="en-US" sz="1300" b="1" dirty="0">
+                <a:solidFill>
+                  <a:srgbClr val="0D3B6E"/>
                 </a:solidFill>
                 <a:latin typeface="Calibri" pitchFamily="34" charset="0"/>
                 <a:ea typeface="Calibri" pitchFamily="34" charset="-122"/>
                 <a:cs typeface="Calibri" pitchFamily="34" charset="-120"/>
               </a:rPr>
-              <a:t>Blue</a:t>
-            </a:r>
-            <a:endParaRPr lang="en-US" sz="1200" dirty="0"/>
-          </a:p>
-        </p:txBody>
-      </p:sp>
-      <p:sp>
-        <p:nvSpPr>
-          <p:cNvPr id="14" name="Shape 12"/>
-          <p:cNvSpPr/>
-          <p:nvPr/>
-        </p:nvSpPr>
-        <p:spPr>
-          <a:xfrm>
-            <a:off x="6263640" y="1691640"/>
-            <a:ext cx="1051560" cy="2011680"/>
-          </a:xfrm>
-          <a:prstGeom prst="rect">
-            <a:avLst/>
-          </a:prstGeom>
-          <a:solidFill>
-            <a:srgbClr val="5C4D7D"/>
+              <a:t>Orange</a:t>
+            </a:r>
+            <a:endParaRPr lang="en-US" sz="1300" dirty="0"/>
+          </a:p>
+        </p:txBody>
+      </p:sp>
+      <p:sp>
+        <p:nvSpPr>
+          <p:cNvPr id="18" name="Text 16"/>
+          <p:cNvSpPr/>
+          <p:nvPr/>
+        </p:nvSpPr>
+        <p:spPr>
+          <a:xfrm>
+            <a:off x="5974080" y="3264408"/>
+            <a:ext cx="1402080" cy="274320"/>
+          </a:xfrm>
+          <a:prstGeom prst="rect">
+            <a:avLst/>
+          </a:prstGeom>
+          <a:noFill/>
+          <a:ln/>
+        </p:spPr>
+        <p:txBody>
+          <a:bodyPr wrap="square" lIns="0" tIns="0" rIns="0" bIns="0" rtlCol="0" anchor="ctr"/>
+          <a:lstStyle/>
+          <a:p>
+            <a:pPr algn="ctr" indent="0" marL="0">
+              <a:buNone/>
+            </a:pPr>
+            <a:r>
+              <a:rPr lang="en-US" sz="1100" dirty="0">
+                <a:solidFill>
+                  <a:srgbClr val="444444"/>
+                </a:solidFill>
+                <a:latin typeface="Calibri" pitchFamily="34" charset="0"/>
+                <a:ea typeface="Calibri" pitchFamily="34" charset="-122"/>
+                <a:cs typeface="Calibri" pitchFamily="34" charset="-120"/>
+              </a:rPr>
+              <a:t>590–620 nm</a:t>
+            </a:r>
+            <a:endParaRPr lang="en-US" sz="1100" dirty="0"/>
+          </a:p>
+        </p:txBody>
+      </p:sp>
+      <p:sp>
+        <p:nvSpPr>
+          <p:cNvPr id="19" name="Shape 17"/>
+          <p:cNvSpPr/>
+          <p:nvPr/>
+        </p:nvSpPr>
+        <p:spPr>
+          <a:xfrm>
+            <a:off x="7376160" y="1234440"/>
+            <a:ext cx="1402080" cy="1645920"/>
+          </a:xfrm>
+          <a:prstGeom prst="rect">
+            <a:avLst/>
+          </a:prstGeom>
+          <a:solidFill>
+            <a:srgbClr val="E8000D"/>
           </a:solidFill>
           <a:ln w="12700">
             <a:solidFill>
-              <a:srgbClr val="5C4D7D"/>
+              <a:srgbClr val="E8000D"/>
             </a:solidFill>
             <a:prstDash val="solid"/>
           </a:ln>
@@ -1847,14 +1897,14 @@
       </p:sp>
       <p:sp>
         <p:nvSpPr>
-          <p:cNvPr id="15" name="Text 13"/>
-          <p:cNvSpPr/>
-          <p:nvPr/>
-        </p:nvSpPr>
-        <p:spPr>
-          <a:xfrm>
-            <a:off x="6263640" y="3749040"/>
-            <a:ext cx="1051560" cy="365760"/>
+          <p:cNvPr id="20" name="Text 18"/>
+          <p:cNvSpPr/>
+          <p:nvPr/>
+        </p:nvSpPr>
+        <p:spPr>
+          <a:xfrm>
+            <a:off x="7376160" y="2953512"/>
+            <a:ext cx="1402080" cy="320040"/>
           </a:xfrm>
           <a:prstGeom prst="rect">
             <a:avLst/>
@@ -1870,40 +1920,77 @@
               <a:buNone/>
             </a:pPr>
             <a:r>
-              <a:rPr lang="en-US" sz="1200" dirty="0">
-                <a:solidFill>
-                  <a:srgbClr val="555555"/>
+              <a:rPr lang="en-US" sz="1300" b="1" dirty="0">
+                <a:solidFill>
+                  <a:srgbClr val="0D3B6E"/>
                 </a:solidFill>
                 <a:latin typeface="Calibri" pitchFamily="34" charset="0"/>
                 <a:ea typeface="Calibri" pitchFamily="34" charset="-122"/>
                 <a:cs typeface="Calibri" pitchFamily="34" charset="-120"/>
               </a:rPr>
-              <a:t>Indigo</a:t>
-            </a:r>
-            <a:endParaRPr lang="en-US" sz="1200" dirty="0"/>
-          </a:p>
-        </p:txBody>
-      </p:sp>
-      <p:sp>
-        <p:nvSpPr>
-          <p:cNvPr id="16" name="Shape 14"/>
-          <p:cNvSpPr/>
-          <p:nvPr/>
-        </p:nvSpPr>
-        <p:spPr>
-          <a:xfrm>
-            <a:off x="7424928" y="1691640"/>
-            <a:ext cx="1051560" cy="2011680"/>
-          </a:xfrm>
-          <a:prstGeom prst="rect">
-            <a:avLst/>
-          </a:prstGeom>
-          <a:solidFill>
-            <a:srgbClr val="9B5DE5"/>
-          </a:solidFill>
-          <a:ln w="12700">
+              <a:t>Red</a:t>
+            </a:r>
+            <a:endParaRPr lang="en-US" sz="1300" dirty="0"/>
+          </a:p>
+        </p:txBody>
+      </p:sp>
+      <p:sp>
+        <p:nvSpPr>
+          <p:cNvPr id="21" name="Text 19"/>
+          <p:cNvSpPr/>
+          <p:nvPr/>
+        </p:nvSpPr>
+        <p:spPr>
+          <a:xfrm>
+            <a:off x="7376160" y="3264408"/>
+            <a:ext cx="1402080" cy="274320"/>
+          </a:xfrm>
+          <a:prstGeom prst="rect">
+            <a:avLst/>
+          </a:prstGeom>
+          <a:noFill/>
+          <a:ln/>
+        </p:spPr>
+        <p:txBody>
+          <a:bodyPr wrap="square" lIns="0" tIns="0" rIns="0" bIns="0" rtlCol="0" anchor="ctr"/>
+          <a:lstStyle/>
+          <a:p>
+            <a:pPr algn="ctr" indent="0" marL="0">
+              <a:buNone/>
+            </a:pPr>
+            <a:r>
+              <a:rPr lang="en-US" sz="1100" dirty="0">
+                <a:solidFill>
+                  <a:srgbClr val="444444"/>
+                </a:solidFill>
+                <a:latin typeface="Calibri" pitchFamily="34" charset="0"/>
+                <a:ea typeface="Calibri" pitchFamily="34" charset="-122"/>
+                <a:cs typeface="Calibri" pitchFamily="34" charset="-120"/>
+              </a:rPr>
+              <a:t>620–750 nm</a:t>
+            </a:r>
+            <a:endParaRPr lang="en-US" sz="1100" dirty="0"/>
+          </a:p>
+        </p:txBody>
+      </p:sp>
+      <p:sp>
+        <p:nvSpPr>
+          <p:cNvPr id="22" name="Shape 20"/>
+          <p:cNvSpPr/>
+          <p:nvPr/>
+        </p:nvSpPr>
+        <p:spPr>
+          <a:xfrm>
+            <a:off x="365760" y="4160520"/>
+            <a:ext cx="8412480" cy="0"/>
+          </a:xfrm>
+          <a:prstGeom prst="line">
+            <a:avLst/>
+          </a:prstGeom>
+          <a:noFill/>
+          <a:ln w="19050">
             <a:solidFill>
-              <a:srgbClr val="9B5DE5"/>
+              <a:srgbClr val="444444"/>
             </a:solidFill>
             <a:prstDash val="solid"/>
           </a:ln>
@@ -1911,14 +1998,14 @@
       </p:sp>
       <p:sp>
         <p:nvSpPr>
-          <p:cNvPr id="17" name="Text 15"/>
-          <p:cNvSpPr/>
-          <p:nvPr/>
-        </p:nvSpPr>
-        <p:spPr>
-          <a:xfrm>
-            <a:off x="7424928" y="3749040"/>
-            <a:ext cx="1051560" cy="365760"/>
+          <p:cNvPr id="23" name="Text 21"/>
+          <p:cNvSpPr/>
+          <p:nvPr/>
+        </p:nvSpPr>
+        <p:spPr>
+          <a:xfrm>
+            <a:off x="365760" y="4251960"/>
+            <a:ext cx="3657600" cy="320040"/>
           </a:xfrm>
           <a:prstGeom prst="rect">
             <a:avLst/>
@@ -1930,19 +2017,19 @@
           <a:bodyPr wrap="square" lIns="0" tIns="0" rIns="0" bIns="0" rtlCol="0" anchor="ctr"/>
           <a:lstStyle/>
           <a:p>
-            <a:pPr algn="ctr" indent="0" marL="0">
-              <a:buNone/>
-            </a:pPr>
-            <a:r>
-              <a:rPr lang="en-US" sz="1200" dirty="0">
-                <a:solidFill>
-                  <a:srgbClr val="555555"/>
+            <a:pPr indent="0" marL="0">
+              <a:buNone/>
+            </a:pPr>
+            <a:r>
+              <a:rPr lang="en-US" sz="1200" b="1" dirty="0">
+                <a:solidFill>
+                  <a:srgbClr val="7B00D4"/>
                 </a:solidFill>
                 <a:latin typeface="Calibri" pitchFamily="34" charset="0"/>
                 <a:ea typeface="Calibri" pitchFamily="34" charset="-122"/>
                 <a:cs typeface="Calibri" pitchFamily="34" charset="-120"/>
               </a:rPr>
-              <a:t>Violet</a:t>
+              <a:t>◄ Short wavelength</a:t>
             </a:r>
             <a:endParaRPr lang="en-US" sz="1200" dirty="0"/>
           </a:p>
@@ -1950,14 +2037,14 @@
       </p:sp>
       <p:sp>
         <p:nvSpPr>
-          <p:cNvPr id="18" name="Text 16"/>
-          <p:cNvSpPr/>
-          <p:nvPr/>
-        </p:nvSpPr>
-        <p:spPr>
-          <a:xfrm>
-            <a:off x="457200" y="4297680"/>
-            <a:ext cx="8229600" cy="457200"/>
+          <p:cNvPr id="24" name="Text 22"/>
+          <p:cNvSpPr/>
+          <p:nvPr/>
+        </p:nvSpPr>
+        <p:spPr>
+          <a:xfrm>
+            <a:off x="5120640" y="4251960"/>
+            <a:ext cx="3657600" cy="320040"/>
           </a:xfrm>
           <a:prstGeom prst="rect">
             <a:avLst/>
@@ -1969,21 +2056,82 @@
           <a:bodyPr wrap="square" lIns="0" tIns="0" rIns="0" bIns="0" rtlCol="0" anchor="ctr"/>
           <a:lstStyle/>
           <a:p>
-            <a:pPr indent="0" marL="0">
-              <a:buNone/>
-            </a:pPr>
-            <a:r>
-              <a:rPr lang="en-US" sz="1400" i="1" dirty="0">
-                <a:solidFill>
-                  <a:srgbClr val="555555"/>
+            <a:pPr algn="r" indent="0" marL="0">
+              <a:buNone/>
+            </a:pPr>
+            <a:r>
+              <a:rPr lang="en-US" sz="1200" b="1" dirty="0">
+                <a:solidFill>
+                  <a:srgbClr val="E8000D"/>
                 </a:solidFill>
                 <a:latin typeface="Calibri" pitchFamily="34" charset="0"/>
                 <a:ea typeface="Calibri" pitchFamily="34" charset="-122"/>
                 <a:cs typeface="Calibri" pitchFamily="34" charset="-120"/>
               </a:rPr>
-              <a:t>All these wavelengths travel together from the Sun to Earth.</a:t>
-            </a:r>
-            <a:endParaRPr lang="en-US" sz="1400" dirty="0"/>
+              <a:t>Long wavelength ►</a:t>
+            </a:r>
+            <a:endParaRPr lang="en-US" sz="1200" dirty="0"/>
+          </a:p>
+        </p:txBody>
+      </p:sp>
+      <p:sp>
+        <p:nvSpPr>
+          <p:cNvPr id="25" name="Shape 23"/>
+          <p:cNvSpPr/>
+          <p:nvPr/>
+        </p:nvSpPr>
+        <p:spPr>
+          <a:xfrm>
+            <a:off x="1722120" y="1143000"/>
+            <a:ext cx="1493520" cy="1828800"/>
+          </a:xfrm>
+          <a:prstGeom prst="rect">
+            <a:avLst/>
+          </a:prstGeom>
+          <a:ln w="38100">
+            <a:solidFill>
+              <a:srgbClr val="FFFFFF"/>
+            </a:solidFill>
+            <a:prstDash val="solid"/>
+          </a:ln>
+        </p:spPr>
+      </p:sp>
+      <p:sp>
+        <p:nvSpPr>
+          <p:cNvPr id="26" name="Text 24"/>
+          <p:cNvSpPr/>
+          <p:nvPr/>
+        </p:nvSpPr>
+        <p:spPr>
+          <a:xfrm>
+            <a:off x="1676400" y="3703320"/>
+            <a:ext cx="1676400" cy="347472"/>
+          </a:xfrm>
+          <a:prstGeom prst="rect">
+            <a:avLst/>
+          </a:prstGeom>
+          <a:noFill/>
+          <a:ln/>
+        </p:spPr>
+        <p:txBody>
+          <a:bodyPr wrap="square" lIns="0" tIns="0" rIns="0" bIns="0" rtlCol="0" anchor="ctr"/>
+          <a:lstStyle/>
+          <a:p>
+            <a:pPr algn="ctr" indent="0" marL="0">
+              <a:buNone/>
+            </a:pPr>
+            <a:r>
+              <a:rPr lang="en-US" sz="1100" b="1" dirty="0">
+                <a:solidFill>
+                  <a:srgbClr val="0D3B6E"/>
+                </a:solidFill>
+                <a:latin typeface="Calibri" pitchFamily="34" charset="0"/>
+                <a:ea typeface="Calibri" pitchFamily="34" charset="-122"/>
+                <a:cs typeface="Calibri" pitchFamily="34" charset="-120"/>
+              </a:rPr>
+              <a:t>⬆ This is the key one</a:t>
+            </a:r>
+            <a:endParaRPr lang="en-US" sz="1100" dirty="0"/>
           </a:p>
         </p:txBody>
       </p:sp>
@@ -2001,7 +2149,7 @@
     <p:bg>
       <p:bgPr>
         <a:solidFill>
-          <a:srgbClr val="EAF4FB"/>
+          <a:srgbClr val="F0F4F8"/>
         </a:solidFill>
       </p:bgPr>
     </p:bg>
@@ -2027,8 +2175,8 @@
         </p:nvSpPr>
         <p:spPr>
           <a:xfrm>
-            <a:off x="457200" y="274320"/>
-            <a:ext cx="8229600" cy="731520"/>
+            <a:off x="457200" y="228600"/>
+            <a:ext cx="8229600" cy="640080"/>
           </a:xfrm>
           <a:prstGeom prst="rect">
             <a:avLst/>
@@ -2044,7 +2192,7 @@
               <a:buNone/>
             </a:pPr>
             <a:r>
-              <a:rPr lang="en-US" sz="3600" b="1" dirty="0">
+              <a:rPr lang="en-US" sz="2800" b="1" dirty="0">
                 <a:solidFill>
                   <a:srgbClr val="0D3B6E"/>
                 </a:solidFill>
@@ -2052,22 +2200,47 @@
                 <a:ea typeface="Georgia" pitchFamily="34" charset="-122"/>
                 <a:cs typeface="Georgia" pitchFamily="34" charset="-120"/>
               </a:rPr>
-              <a:t>Meet: Rayleigh Scattering</a:t>
-            </a:r>
-            <a:endParaRPr lang="en-US" sz="3600" dirty="0"/>
-          </a:p>
-        </p:txBody>
-      </p:sp>
-      <p:sp>
-        <p:nvSpPr>
-          <p:cNvPr id="3" name="Text 1"/>
-          <p:cNvSpPr/>
-          <p:nvPr/>
-        </p:nvSpPr>
-        <p:spPr>
-          <a:xfrm>
-            <a:off x="457200" y="1143000"/>
-            <a:ext cx="4846320" cy="3474720"/>
+              <a:t>Short wavelengths scatter more</a:t>
+            </a:r>
+            <a:endParaRPr lang="en-US" sz="2800" dirty="0"/>
+          </a:p>
+        </p:txBody>
+      </p:sp>
+      <p:sp>
+        <p:nvSpPr>
+          <p:cNvPr id="3" name="Shape 1"/>
+          <p:cNvSpPr/>
+          <p:nvPr/>
+        </p:nvSpPr>
+        <p:spPr>
+          <a:xfrm>
+            <a:off x="274320" y="1188720"/>
+            <a:ext cx="914400" cy="914400"/>
+          </a:xfrm>
+          <a:prstGeom prst="ellipse">
+            <a:avLst/>
+          </a:prstGeom>
+          <a:solidFill>
+            <a:srgbClr val="F5C842"/>
+          </a:solidFill>
+          <a:ln w="12700">
+            <a:solidFill>
+              <a:srgbClr val="F5C842"/>
+            </a:solidFill>
+            <a:prstDash val="solid"/>
+          </a:ln>
+        </p:spPr>
+      </p:sp>
+      <p:sp>
+        <p:nvSpPr>
+          <p:cNvPr id="4" name="Text 2"/>
+          <p:cNvSpPr/>
+          <p:nvPr/>
+        </p:nvSpPr>
+        <p:spPr>
+          <a:xfrm>
+            <a:off x="274320" y="1188720"/>
+            <a:ext cx="914400" cy="914400"/>
           </a:xfrm>
           <a:prstGeom prst="rect">
             <a:avLst/>
@@ -2079,111 +2252,62 @@
           <a:bodyPr wrap="square" lIns="0" tIns="0" rIns="0" bIns="0" rtlCol="0" anchor="ctr"/>
           <a:lstStyle/>
           <a:p>
-            <a:pPr indent="0" marL="0">
-              <a:buNone/>
-            </a:pPr>
-            <a:r>
-              <a:rPr lang="en-US" sz="1500" dirty="0">
-                <a:solidFill>
-                  <a:srgbClr val="555555"/>
-                </a:solidFill>
-                <a:latin typeface="Calibri" pitchFamily="34" charset="0"/>
-                <a:ea typeface="Calibri" pitchFamily="34" charset="-122"/>
-                <a:cs typeface="Calibri" pitchFamily="34" charset="-120"/>
-              </a:rPr>
-              <a:t>When sunlight hits Earth's atmosphere, it collides with tiny gas molecules (mostly nitrogen and oxygen).</a:t>
-            </a:r>
-            <a:endParaRPr lang="en-US" sz="1500" dirty="0"/>
-          </a:p>
-          <a:p>
-            <a:pPr indent="0" marL="0">
-              <a:buNone/>
-            </a:pPr>
-            <a:endParaRPr lang="en-US" sz="1500" dirty="0"/>
-          </a:p>
-          <a:p>
-            <a:pPr indent="0" marL="0">
-              <a:buNone/>
-            </a:pPr>
-            <a:r>
-              <a:rPr lang="en-US" sz="1500" dirty="0">
-                <a:solidFill>
-                  <a:srgbClr val="555555"/>
-                </a:solidFill>
-                <a:latin typeface="Calibri" pitchFamily="34" charset="0"/>
-                <a:ea typeface="Calibri" pitchFamily="34" charset="-122"/>
-                <a:cs typeface="Calibri" pitchFamily="34" charset="-120"/>
-              </a:rPr>
-              <a:t>These molecules scatter light — but they scatter SHORT wavelengths much more than long ones.</a:t>
-            </a:r>
-            <a:endParaRPr lang="en-US" sz="1500" dirty="0"/>
-          </a:p>
-          <a:p>
-            <a:pPr indent="0" marL="0">
-              <a:buNone/>
-            </a:pPr>
-            <a:endParaRPr lang="en-US" sz="1500" dirty="0"/>
-          </a:p>
-          <a:p>
-            <a:pPr indent="0" marL="0">
-              <a:buNone/>
-            </a:pPr>
-            <a:r>
-              <a:rPr lang="en-US" sz="1500" dirty="0">
-                <a:solidFill>
-                  <a:srgbClr val="555555"/>
-                </a:solidFill>
-                <a:latin typeface="Calibri" pitchFamily="34" charset="0"/>
-                <a:ea typeface="Calibri" pitchFamily="34" charset="-122"/>
-                <a:cs typeface="Calibri" pitchFamily="34" charset="-120"/>
-              </a:rPr>
-              <a:t>Blue light has a short wavelength → it gets scattered in ALL directions across the sky.</a:t>
-            </a:r>
-            <a:endParaRPr lang="en-US" sz="1500" dirty="0"/>
-          </a:p>
-          <a:p>
-            <a:pPr indent="0" marL="0">
-              <a:buNone/>
-            </a:pPr>
-            <a:endParaRPr lang="en-US" sz="1500" dirty="0"/>
-          </a:p>
-          <a:p>
-            <a:pPr indent="0" marL="0">
-              <a:buNone/>
-            </a:pPr>
-            <a:r>
-              <a:rPr lang="en-US" sz="1500" dirty="0">
-                <a:solidFill>
-                  <a:srgbClr val="555555"/>
-                </a:solidFill>
-                <a:latin typeface="Calibri" pitchFamily="34" charset="0"/>
-                <a:ea typeface="Calibri" pitchFamily="34" charset="-122"/>
-                <a:cs typeface="Calibri" pitchFamily="34" charset="-120"/>
-              </a:rPr>
-              <a:t>Red &amp; orange have long wavelengths → they pass straight through.</a:t>
-            </a:r>
-            <a:endParaRPr lang="en-US" sz="1500" dirty="0"/>
-          </a:p>
-        </p:txBody>
-      </p:sp>
-      <p:sp>
-        <p:nvSpPr>
-          <p:cNvPr id="4" name="Shape 2"/>
-          <p:cNvSpPr/>
-          <p:nvPr/>
-        </p:nvSpPr>
-        <p:spPr>
-          <a:xfrm>
-            <a:off x="5943600" y="1371600"/>
-            <a:ext cx="457200" cy="457200"/>
+            <a:pPr algn="ctr" indent="0" marL="0">
+              <a:buNone/>
+            </a:pPr>
+            <a:r>
+              <a:rPr lang="en-US" sz="1000" b="1" dirty="0">
+                <a:solidFill>
+                  <a:srgbClr val="0D3B6E"/>
+                </a:solidFill>
+              </a:rPr>
+              <a:t>SUN</a:t>
+            </a:r>
+            <a:endParaRPr lang="en-US" sz="1000" dirty="0"/>
+          </a:p>
+        </p:txBody>
+      </p:sp>
+      <p:sp>
+        <p:nvSpPr>
+          <p:cNvPr id="5" name="Shape 3"/>
+          <p:cNvSpPr/>
+          <p:nvPr/>
+        </p:nvSpPr>
+        <p:spPr>
+          <a:xfrm>
+            <a:off x="1234440" y="1645920"/>
+            <a:ext cx="1371600" cy="0"/>
+          </a:xfrm>
+          <a:prstGeom prst="line">
+            <a:avLst/>
+          </a:prstGeom>
+          <a:noFill/>
+          <a:ln w="38100">
+            <a:solidFill>
+              <a:srgbClr val="AAAAAA"/>
+            </a:solidFill>
+            <a:prstDash val="solid"/>
+          </a:ln>
+        </p:spPr>
+      </p:sp>
+      <p:sp>
+        <p:nvSpPr>
+          <p:cNvPr id="6" name="Shape 4"/>
+          <p:cNvSpPr/>
+          <p:nvPr/>
+        </p:nvSpPr>
+        <p:spPr>
+          <a:xfrm>
+            <a:off x="2651760" y="1234440"/>
+            <a:ext cx="1371600" cy="822960"/>
           </a:xfrm>
           <a:prstGeom prst="ellipse">
             <a:avLst/>
           </a:prstGeom>
           <a:solidFill>
-            <a:srgbClr val="1A78C2"/>
-          </a:solidFill>
-          <a:ln w="12700">
+            <a:srgbClr val="D0E8FF"/>
+          </a:solidFill>
+          <a:ln w="25400">
             <a:solidFill>
               <a:srgbClr val="1A78C2"/>
             </a:solidFill>
@@ -2193,24 +2317,72 @@
       </p:sp>
       <p:sp>
         <p:nvSpPr>
-          <p:cNvPr id="5" name="Shape 3"/>
-          <p:cNvSpPr/>
-          <p:nvPr/>
-        </p:nvSpPr>
-        <p:spPr>
-          <a:xfrm>
-            <a:off x="6766560" y="1097280"/>
-            <a:ext cx="457200" cy="457200"/>
-          </a:xfrm>
-          <a:prstGeom prst="ellipse">
-            <a:avLst/>
-          </a:prstGeom>
-          <a:solidFill>
-            <a:srgbClr val="1A78C2"/>
-          </a:solidFill>
-          <a:ln w="12700">
+          <p:cNvPr id="7" name="Text 5"/>
+          <p:cNvSpPr/>
+          <p:nvPr/>
+        </p:nvSpPr>
+        <p:spPr>
+          <a:xfrm>
+            <a:off x="2651760" y="1234440"/>
+            <a:ext cx="1371600" cy="822960"/>
+          </a:xfrm>
+          <a:prstGeom prst="rect">
+            <a:avLst/>
+          </a:prstGeom>
+          <a:noFill/>
+          <a:ln/>
+        </p:spPr>
+        <p:txBody>
+          <a:bodyPr wrap="square" lIns="0" tIns="0" rIns="0" bIns="0" rtlCol="0" anchor="ctr"/>
+          <a:lstStyle/>
+          <a:p>
+            <a:pPr algn="ctr" indent="0" marL="0">
+              <a:buNone/>
+            </a:pPr>
+            <a:r>
+              <a:rPr lang="en-US" sz="900" dirty="0">
+                <a:solidFill>
+                  <a:srgbClr val="0D3B6E"/>
+                </a:solidFill>
+              </a:rPr>
+              <a:t>atmosphere</a:t>
+            </a:r>
+            <a:endParaRPr lang="en-US" sz="900" dirty="0"/>
+          </a:p>
+          <a:p>
+            <a:pPr algn="ctr" indent="0" marL="0">
+              <a:buNone/>
+            </a:pPr>
+            <a:r>
+              <a:rPr lang="en-US" sz="900" dirty="0">
+                <a:solidFill>
+                  <a:srgbClr val="0D3B6E"/>
+                </a:solidFill>
+              </a:rPr>
+              <a:t>molecule</a:t>
+            </a:r>
+            <a:endParaRPr lang="en-US" sz="900" dirty="0"/>
+          </a:p>
+        </p:txBody>
+      </p:sp>
+      <p:sp>
+        <p:nvSpPr>
+          <p:cNvPr id="8" name="Shape 6"/>
+          <p:cNvSpPr/>
+          <p:nvPr/>
+        </p:nvSpPr>
+        <p:spPr>
+          <a:xfrm>
+            <a:off x="3337560" y="1234440"/>
+            <a:ext cx="0" cy="-822960"/>
+          </a:xfrm>
+          <a:prstGeom prst="line">
+            <a:avLst/>
+          </a:prstGeom>
+          <a:noFill/>
+          <a:ln w="38100">
             <a:solidFill>
-              <a:srgbClr val="1A78C2"/>
+              <a:srgbClr val="3B4FE0"/>
             </a:solidFill>
             <a:prstDash val="solid"/>
           </a:ln>
@@ -2218,24 +2390,22 @@
       </p:sp>
       <p:sp>
         <p:nvSpPr>
-          <p:cNvPr id="6" name="Shape 4"/>
-          <p:cNvSpPr/>
-          <p:nvPr/>
-        </p:nvSpPr>
-        <p:spPr>
-          <a:xfrm>
-            <a:off x="7498080" y="1554480"/>
-            <a:ext cx="457200" cy="457200"/>
-          </a:xfrm>
-          <a:prstGeom prst="ellipse">
-            <a:avLst/>
-          </a:prstGeom>
-          <a:solidFill>
-            <a:srgbClr val="1A78C2"/>
-          </a:solidFill>
-          <a:ln w="12700">
+          <p:cNvPr id="9" name="Shape 7"/>
+          <p:cNvSpPr/>
+          <p:nvPr/>
+        </p:nvSpPr>
+        <p:spPr>
+          <a:xfrm>
+            <a:off x="3337560" y="2057400"/>
+            <a:ext cx="0" cy="822960"/>
+          </a:xfrm>
+          <a:prstGeom prst="line">
+            <a:avLst/>
+          </a:prstGeom>
+          <a:noFill/>
+          <a:ln w="38100">
             <a:solidFill>
-              <a:srgbClr val="1A78C2"/>
+              <a:srgbClr val="3B4FE0"/>
             </a:solidFill>
             <a:prstDash val="solid"/>
           </a:ln>
@@ -2243,24 +2413,95 @@
       </p:sp>
       <p:sp>
         <p:nvSpPr>
-          <p:cNvPr id="7" name="Shape 5"/>
-          <p:cNvSpPr/>
-          <p:nvPr/>
-        </p:nvSpPr>
-        <p:spPr>
-          <a:xfrm>
-            <a:off x="6217920" y="2286000"/>
-            <a:ext cx="457200" cy="457200"/>
-          </a:xfrm>
-          <a:prstGeom prst="ellipse">
-            <a:avLst/>
-          </a:prstGeom>
-          <a:solidFill>
-            <a:srgbClr val="1A78C2"/>
-          </a:solidFill>
-          <a:ln w="12700">
+          <p:cNvPr id="10" name="Text 8"/>
+          <p:cNvSpPr/>
+          <p:nvPr/>
+        </p:nvSpPr>
+        <p:spPr>
+          <a:xfrm>
+            <a:off x="2468880" y="2971800"/>
+            <a:ext cx="2286000" cy="731520"/>
+          </a:xfrm>
+          <a:prstGeom prst="rect">
+            <a:avLst/>
+          </a:prstGeom>
+          <a:noFill/>
+          <a:ln/>
+        </p:spPr>
+        <p:txBody>
+          <a:bodyPr wrap="square" lIns="0" tIns="0" rIns="0" bIns="0" rtlCol="0" anchor="ctr"/>
+          <a:lstStyle/>
+          <a:p>
+            <a:pPr algn="ctr" indent="0" marL="0">
+              <a:buNone/>
+            </a:pPr>
+            <a:r>
+              <a:rPr lang="en-US" sz="1200" b="1" dirty="0">
+                <a:solidFill>
+                  <a:srgbClr val="3B4FE0"/>
+                </a:solidFill>
+                <a:latin typeface="Calibri" pitchFamily="34" charset="0"/>
+                <a:ea typeface="Calibri" pitchFamily="34" charset="-122"/>
+                <a:cs typeface="Calibri" pitchFamily="34" charset="-120"/>
+              </a:rPr>
+              <a:t>Blue (450 nm)</a:t>
+            </a:r>
+            <a:endParaRPr lang="en-US" sz="1200" dirty="0"/>
+          </a:p>
+          <a:p>
+            <a:pPr algn="ctr" indent="0" marL="0">
+              <a:buNone/>
+            </a:pPr>
+            <a:r>
+              <a:rPr lang="en-US" sz="1200" b="1" dirty="0">
+                <a:solidFill>
+                  <a:srgbClr val="3B4FE0"/>
+                </a:solidFill>
+                <a:latin typeface="Calibri" pitchFamily="34" charset="0"/>
+                <a:ea typeface="Calibri" pitchFamily="34" charset="-122"/>
+                <a:cs typeface="Calibri" pitchFamily="34" charset="-120"/>
+              </a:rPr>
+              <a:t>scatters away →</a:t>
+            </a:r>
+            <a:endParaRPr lang="en-US" sz="1200" dirty="0"/>
+          </a:p>
+          <a:p>
+            <a:pPr algn="ctr" indent="0" marL="0">
+              <a:buNone/>
+            </a:pPr>
+            <a:r>
+              <a:rPr lang="en-US" sz="1200" b="1" dirty="0">
+                <a:solidFill>
+                  <a:srgbClr val="3B4FE0"/>
+                </a:solidFill>
+                <a:latin typeface="Calibri" pitchFamily="34" charset="0"/>
+                <a:ea typeface="Calibri" pitchFamily="34" charset="-122"/>
+                <a:cs typeface="Calibri" pitchFamily="34" charset="-120"/>
+              </a:rPr>
+              <a:t>fills the whole sky</a:t>
+            </a:r>
+            <a:endParaRPr lang="en-US" sz="1200" dirty="0"/>
+          </a:p>
+        </p:txBody>
+      </p:sp>
+      <p:sp>
+        <p:nvSpPr>
+          <p:cNvPr id="11" name="Shape 9"/>
+          <p:cNvSpPr/>
+          <p:nvPr/>
+        </p:nvSpPr>
+        <p:spPr>
+          <a:xfrm>
+            <a:off x="4069080" y="1645920"/>
+            <a:ext cx="2560320" cy="0"/>
+          </a:xfrm>
+          <a:prstGeom prst="line">
+            <a:avLst/>
+          </a:prstGeom>
+          <a:noFill/>
+          <a:ln w="38100">
             <a:solidFill>
-              <a:srgbClr val="1A78C2"/>
+              <a:srgbClr val="E8000D"/>
             </a:solidFill>
             <a:prstDash val="solid"/>
           </a:ln>
@@ -2268,24 +2509,80 @@
       </p:sp>
       <p:sp>
         <p:nvSpPr>
-          <p:cNvPr id="8" name="Shape 6"/>
-          <p:cNvSpPr/>
-          <p:nvPr/>
-        </p:nvSpPr>
-        <p:spPr>
-          <a:xfrm>
-            <a:off x="7315200" y="2560320"/>
-            <a:ext cx="457200" cy="457200"/>
+          <p:cNvPr id="12" name="Text 10"/>
+          <p:cNvSpPr/>
+          <p:nvPr/>
+        </p:nvSpPr>
+        <p:spPr>
+          <a:xfrm>
+            <a:off x="4663440" y="777240"/>
+            <a:ext cx="2286000" cy="411480"/>
+          </a:xfrm>
+          <a:prstGeom prst="rect">
+            <a:avLst/>
+          </a:prstGeom>
+          <a:noFill/>
+          <a:ln/>
+        </p:spPr>
+        <p:txBody>
+          <a:bodyPr wrap="square" lIns="0" tIns="0" rIns="0" bIns="0" rtlCol="0" anchor="ctr"/>
+          <a:lstStyle/>
+          <a:p>
+            <a:pPr algn="ctr" indent="0" marL="0">
+              <a:buNone/>
+            </a:pPr>
+            <a:r>
+              <a:rPr lang="en-US" sz="1200" b="1" dirty="0">
+                <a:solidFill>
+                  <a:srgbClr val="E8000D"/>
+                </a:solidFill>
+                <a:latin typeface="Calibri" pitchFamily="34" charset="0"/>
+                <a:ea typeface="Calibri" pitchFamily="34" charset="-122"/>
+                <a:cs typeface="Calibri" pitchFamily="34" charset="-120"/>
+              </a:rPr>
+              <a:t>Red (700 nm)</a:t>
+            </a:r>
+            <a:endParaRPr lang="en-US" sz="1200" dirty="0"/>
+          </a:p>
+          <a:p>
+            <a:pPr algn="ctr" indent="0" marL="0">
+              <a:buNone/>
+            </a:pPr>
+            <a:r>
+              <a:rPr lang="en-US" sz="1200" b="1" dirty="0">
+                <a:solidFill>
+                  <a:srgbClr val="E8000D"/>
+                </a:solidFill>
+                <a:latin typeface="Calibri" pitchFamily="34" charset="0"/>
+                <a:ea typeface="Calibri" pitchFamily="34" charset="-122"/>
+                <a:cs typeface="Calibri" pitchFamily="34" charset="-120"/>
+              </a:rPr>
+              <a:t>passes straight through</a:t>
+            </a:r>
+            <a:endParaRPr lang="en-US" sz="1200" dirty="0"/>
+          </a:p>
+        </p:txBody>
+      </p:sp>
+      <p:sp>
+        <p:nvSpPr>
+          <p:cNvPr id="13" name="Shape 11"/>
+          <p:cNvSpPr/>
+          <p:nvPr/>
+        </p:nvSpPr>
+        <p:spPr>
+          <a:xfrm>
+            <a:off x="6766560" y="1371600"/>
+            <a:ext cx="640080" cy="548640"/>
           </a:xfrm>
           <a:prstGeom prst="ellipse">
             <a:avLst/>
           </a:prstGeom>
           <a:solidFill>
-            <a:srgbClr val="1A78C2"/>
+            <a:srgbClr val="FFFFFF"/>
           </a:solidFill>
           <a:ln w="12700">
             <a:solidFill>
-              <a:srgbClr val="1A78C2"/>
+              <a:srgbClr val="444444"/>
             </a:solidFill>
             <a:prstDash val="solid"/>
           </a:ln>
@@ -2293,39 +2590,14 @@
       </p:sp>
       <p:sp>
         <p:nvSpPr>
-          <p:cNvPr id="9" name="Shape 7"/>
-          <p:cNvSpPr/>
-          <p:nvPr/>
-        </p:nvSpPr>
-        <p:spPr>
-          <a:xfrm>
-            <a:off x="6583680" y="3017520"/>
-            <a:ext cx="457200" cy="457200"/>
-          </a:xfrm>
-          <a:prstGeom prst="ellipse">
-            <a:avLst/>
-          </a:prstGeom>
-          <a:solidFill>
-            <a:srgbClr val="1A78C2"/>
-          </a:solidFill>
-          <a:ln w="12700">
-            <a:solidFill>
-              <a:srgbClr val="1A78C2"/>
-            </a:solidFill>
-            <a:prstDash val="solid"/>
-          </a:ln>
-        </p:spPr>
-      </p:sp>
-      <p:sp>
-        <p:nvSpPr>
-          <p:cNvPr id="10" name="Shape 8"/>
-          <p:cNvSpPr/>
-          <p:nvPr/>
-        </p:nvSpPr>
-        <p:spPr>
-          <a:xfrm>
-            <a:off x="6537960" y="1920240"/>
-            <a:ext cx="640080" cy="640080"/>
+          <p:cNvPr id="14" name="Shape 12"/>
+          <p:cNvSpPr/>
+          <p:nvPr/>
+        </p:nvSpPr>
+        <p:spPr>
+          <a:xfrm>
+            <a:off x="6949440" y="1481328"/>
+            <a:ext cx="274320" cy="274320"/>
           </a:xfrm>
           <a:prstGeom prst="ellipse">
             <a:avLst/>
@@ -2343,14 +2615,14 @@
       </p:sp>
       <p:sp>
         <p:nvSpPr>
-          <p:cNvPr id="11" name="Text 9"/>
-          <p:cNvSpPr/>
-          <p:nvPr/>
-        </p:nvSpPr>
-        <p:spPr>
-          <a:xfrm>
-            <a:off x="6263640" y="2606040"/>
-            <a:ext cx="1188720" cy="274320"/>
+          <p:cNvPr id="15" name="Text 13"/>
+          <p:cNvSpPr/>
+          <p:nvPr/>
+        </p:nvSpPr>
+        <p:spPr>
+          <a:xfrm>
+            <a:off x="6583680" y="1965960"/>
+            <a:ext cx="1097280" cy="274320"/>
           </a:xfrm>
           <a:prstGeom prst="rect">
             <a:avLst/>
@@ -2368,13 +2640,13 @@
             <a:r>
               <a:rPr lang="en-US" sz="1000" dirty="0">
                 <a:solidFill>
-                  <a:srgbClr val="555555"/>
+                  <a:srgbClr val="444444"/>
                 </a:solidFill>
                 <a:latin typeface="Calibri" pitchFamily="34" charset="0"/>
                 <a:ea typeface="Calibri" pitchFamily="34" charset="-122"/>
                 <a:cs typeface="Calibri" pitchFamily="34" charset="-120"/>
               </a:rPr>
-              <a:t>molecule</a:t>
+              <a:t>your eye</a:t>
             </a:r>
             <a:endParaRPr lang="en-US" sz="1000" dirty="0"/>
           </a:p>
@@ -2382,14 +2654,39 @@
       </p:sp>
       <p:sp>
         <p:nvSpPr>
-          <p:cNvPr id="12" name="Text 10"/>
-          <p:cNvSpPr/>
-          <p:nvPr/>
-        </p:nvSpPr>
-        <p:spPr>
-          <a:xfrm>
-            <a:off x="5852160" y="3383280"/>
-            <a:ext cx="2560320" cy="548640"/>
+          <p:cNvPr id="16" name="Shape 14"/>
+          <p:cNvSpPr/>
+          <p:nvPr/>
+        </p:nvSpPr>
+        <p:spPr>
+          <a:xfrm>
+            <a:off x="457200" y="3931920"/>
+            <a:ext cx="8229600" cy="868680"/>
+          </a:xfrm>
+          <a:prstGeom prst="rect">
+            <a:avLst/>
+          </a:prstGeom>
+          <a:solidFill>
+            <a:srgbClr val="0D3B6E"/>
+          </a:solidFill>
+          <a:ln w="12700">
+            <a:solidFill>
+              <a:srgbClr val="0D3B6E"/>
+            </a:solidFill>
+            <a:prstDash val="solid"/>
+          </a:ln>
+        </p:spPr>
+      </p:sp>
+      <p:sp>
+        <p:nvSpPr>
+          <p:cNvPr id="17" name="Text 15"/>
+          <p:cNvSpPr/>
+          <p:nvPr/>
+        </p:nvSpPr>
+        <p:spPr>
+          <a:xfrm>
+            <a:off x="594360" y="3977640"/>
+            <a:ext cx="7955280" cy="777240"/>
           </a:xfrm>
           <a:prstGeom prst="rect">
             <a:avLst/>
@@ -2401,38 +2698,21 @@
           <a:bodyPr wrap="square" lIns="0" tIns="0" rIns="0" bIns="0" rtlCol="0" anchor="ctr"/>
           <a:lstStyle/>
           <a:p>
-            <a:pPr algn="ctr" indent="0" marL="0">
-              <a:buNone/>
-            </a:pPr>
-            <a:r>
-              <a:rPr lang="en-US" sz="1200" b="1" dirty="0">
-                <a:solidFill>
-                  <a:srgbClr val="1A78C2"/>
+            <a:pPr indent="0" marL="0">
+              <a:buNone/>
+            </a:pPr>
+            <a:r>
+              <a:rPr lang="en-US" sz="1400" dirty="0">
+                <a:solidFill>
+                  <a:srgbClr val="FFFFFF"/>
                 </a:solidFill>
                 <a:latin typeface="Calibri" pitchFamily="34" charset="0"/>
                 <a:ea typeface="Calibri" pitchFamily="34" charset="-122"/>
                 <a:cs typeface="Calibri" pitchFamily="34" charset="-120"/>
               </a:rPr>
-              <a:t>🔵 blue light</a:t>
-            </a:r>
-            <a:endParaRPr lang="en-US" sz="1200" dirty="0"/>
-          </a:p>
-          <a:p>
-            <a:pPr algn="ctr" indent="0" marL="0">
-              <a:buNone/>
-            </a:pPr>
-            <a:r>
-              <a:rPr lang="en-US" sz="1200" b="1" dirty="0">
-                <a:solidFill>
-                  <a:srgbClr val="1A78C2"/>
-                </a:solidFill>
-                <a:latin typeface="Calibri" pitchFamily="34" charset="0"/>
-                <a:ea typeface="Calibri" pitchFamily="34" charset="-122"/>
-                <a:cs typeface="Calibri" pitchFamily="34" charset="-120"/>
-              </a:rPr>
-              <a:t>scattered everywhere</a:t>
-            </a:r>
-            <a:endParaRPr lang="en-US" sz="1200" dirty="0"/>
+              <a:t>Blue light (short wavelength) bounces off molecules in all directions → your eyes see blue everywhere you look up.</a:t>
+            </a:r>
+            <a:endParaRPr lang="en-US" sz="1400" dirty="0"/>
           </a:p>
         </p:txBody>
       </p:sp>
@@ -2470,14 +2750,78 @@
       </p:grpSpPr>
       <p:sp>
         <p:nvSpPr>
-          <p:cNvPr id="2" name="Shape 0"/>
-          <p:cNvSpPr/>
-          <p:nvPr/>
-        </p:nvSpPr>
-        <p:spPr>
-          <a:xfrm>
-            <a:off x="0" y="2286000"/>
-            <a:ext cx="9144000" cy="2857500"/>
+          <p:cNvPr id="2" name="Text 0"/>
+          <p:cNvSpPr/>
+          <p:nvPr/>
+        </p:nvSpPr>
+        <p:spPr>
+          <a:xfrm>
+            <a:off x="457200" y="182880"/>
+            <a:ext cx="8229600" cy="640080"/>
+          </a:xfrm>
+          <a:prstGeom prst="rect">
+            <a:avLst/>
+          </a:prstGeom>
+          <a:noFill/>
+          <a:ln/>
+        </p:spPr>
+        <p:txBody>
+          <a:bodyPr wrap="square" lIns="0" tIns="0" rIns="0" bIns="0" rtlCol="0" anchor="ctr"/>
+          <a:lstStyle/>
+          <a:p>
+            <a:pPr indent="0" marL="0">
+              <a:buNone/>
+            </a:pPr>
+            <a:r>
+              <a:rPr lang="en-US" sz="2800" b="1" dirty="0">
+                <a:solidFill>
+                  <a:srgbClr val="F5C842"/>
+                </a:solidFill>
+                <a:latin typeface="Georgia" pitchFamily="34" charset="0"/>
+                <a:ea typeface="Georgia" pitchFamily="34" charset="-122"/>
+                <a:cs typeface="Georgia" pitchFamily="34" charset="-120"/>
+              </a:rPr>
+              <a:t>Bonus: Why are sunsets orange &amp; red?</a:t>
+            </a:r>
+            <a:endParaRPr lang="en-US" sz="2800" dirty="0"/>
+          </a:p>
+        </p:txBody>
+      </p:sp>
+      <p:sp>
+        <p:nvSpPr>
+          <p:cNvPr id="3" name="Shape 1"/>
+          <p:cNvSpPr/>
+          <p:nvPr/>
+        </p:nvSpPr>
+        <p:spPr>
+          <a:xfrm>
+            <a:off x="0" y="960120"/>
+            <a:ext cx="9144000" cy="594360"/>
+          </a:xfrm>
+          <a:prstGeom prst="rect">
+            <a:avLst/>
+          </a:prstGeom>
+          <a:solidFill>
+            <a:srgbClr val="F25C54"/>
+          </a:solidFill>
+          <a:ln w="12700">
+            <a:solidFill>
+              <a:srgbClr val="F25C54"/>
+            </a:solidFill>
+            <a:prstDash val="solid"/>
+          </a:ln>
+        </p:spPr>
+      </p:sp>
+      <p:sp>
+        <p:nvSpPr>
+          <p:cNvPr id="4" name="Shape 2"/>
+          <p:cNvSpPr/>
+          <p:nvPr/>
+        </p:nvSpPr>
+        <p:spPr>
+          <a:xfrm>
+            <a:off x="0" y="1554480"/>
+            <a:ext cx="9144000" cy="594360"/>
           </a:xfrm>
           <a:prstGeom prst="rect">
             <a:avLst/>
@@ -2495,14 +2839,14 @@
       </p:sp>
       <p:sp>
         <p:nvSpPr>
-          <p:cNvPr id="3" name="Shape 1"/>
-          <p:cNvSpPr/>
-          <p:nvPr/>
-        </p:nvSpPr>
-        <p:spPr>
-          <a:xfrm>
-            <a:off x="0" y="1371600"/>
-            <a:ext cx="9144000" cy="1097280"/>
+          <p:cNvPr id="5" name="Shape 3"/>
+          <p:cNvSpPr/>
+          <p:nvPr/>
+        </p:nvSpPr>
+        <p:spPr>
+          <a:xfrm>
+            <a:off x="0" y="2148840"/>
+            <a:ext cx="9144000" cy="594360"/>
           </a:xfrm>
           <a:prstGeom prst="rect">
             <a:avLst/>
@@ -2520,39 +2864,14 @@
       </p:sp>
       <p:sp>
         <p:nvSpPr>
-          <p:cNvPr id="4" name="Shape 2"/>
-          <p:cNvSpPr/>
-          <p:nvPr/>
-        </p:nvSpPr>
-        <p:spPr>
-          <a:xfrm>
-            <a:off x="0" y="731520"/>
-            <a:ext cx="9144000" cy="822960"/>
-          </a:xfrm>
-          <a:prstGeom prst="rect">
-            <a:avLst/>
-          </a:prstGeom>
-          <a:solidFill>
-            <a:srgbClr val="F25C54"/>
-          </a:solidFill>
-          <a:ln w="12700">
-            <a:solidFill>
-              <a:srgbClr val="F25C54"/>
-            </a:solidFill>
-            <a:prstDash val="solid"/>
-          </a:ln>
-        </p:spPr>
-      </p:sp>
-      <p:sp>
-        <p:nvSpPr>
-          <p:cNvPr id="5" name="Text 3"/>
-          <p:cNvSpPr/>
-          <p:nvPr/>
-        </p:nvSpPr>
-        <p:spPr>
-          <a:xfrm>
-            <a:off x="457200" y="45720"/>
-            <a:ext cx="8229600" cy="640080"/>
+          <p:cNvPr id="6" name="Text 4"/>
+          <p:cNvSpPr/>
+          <p:nvPr/>
+        </p:nvSpPr>
+        <p:spPr>
+          <a:xfrm>
+            <a:off x="457200" y="2880360"/>
+            <a:ext cx="8229600" cy="1097280"/>
           </a:xfrm>
           <a:prstGeom prst="rect">
             <a:avLst/>
@@ -2568,7 +2887,80 @@
               <a:buNone/>
             </a:pPr>
             <a:r>
-              <a:rPr lang="en-US" sz="3000" b="1" dirty="0">
+              <a:rPr lang="en-US" sz="1500" dirty="0">
+                <a:solidFill>
+                  <a:srgbClr val="FFFFFF"/>
+                </a:solidFill>
+                <a:latin typeface="Calibri" pitchFamily="34" charset="0"/>
+                <a:ea typeface="Calibri" pitchFamily="34" charset="-122"/>
+                <a:cs typeface="Calibri" pitchFamily="34" charset="-120"/>
+              </a:rPr>
+              <a:t>At sunset, sunlight travels through much MORE atmosphere to reach you.</a:t>
+            </a:r>
+            <a:endParaRPr lang="en-US" sz="1500" dirty="0"/>
+          </a:p>
+          <a:p>
+            <a:pPr indent="0" marL="0">
+              <a:buNone/>
+            </a:pPr>
+            <a:r>
+              <a:rPr lang="en-US" sz="1500" dirty="0">
+                <a:solidFill>
+                  <a:srgbClr val="FFFFFF"/>
+                </a:solidFill>
+                <a:latin typeface="Calibri" pitchFamily="34" charset="0"/>
+                <a:ea typeface="Calibri" pitchFamily="34" charset="-122"/>
+                <a:cs typeface="Calibri" pitchFamily="34" charset="-120"/>
+              </a:rPr>
+              <a:t>All the blue (short wavelength) gets scattered away before it arrives.</a:t>
+            </a:r>
+            <a:endParaRPr lang="en-US" sz="1500" dirty="0"/>
+          </a:p>
+          <a:p>
+            <a:pPr indent="0" marL="0">
+              <a:buNone/>
+            </a:pPr>
+            <a:r>
+              <a:rPr lang="en-US" sz="1500" dirty="0">
+                <a:solidFill>
+                  <a:srgbClr val="FFFFFF"/>
+                </a:solidFill>
+                <a:latin typeface="Calibri" pitchFamily="34" charset="0"/>
+                <a:ea typeface="Calibri" pitchFamily="34" charset="-122"/>
+                <a:cs typeface="Calibri" pitchFamily="34" charset="-120"/>
+              </a:rPr>
+              <a:t>Only red &amp; orange (long wavelength, 620–750 nm) survive the long trip.</a:t>
+            </a:r>
+            <a:endParaRPr lang="en-US" sz="1500" dirty="0"/>
+          </a:p>
+        </p:txBody>
+      </p:sp>
+      <p:sp>
+        <p:nvSpPr>
+          <p:cNvPr id="7" name="Text 5"/>
+          <p:cNvSpPr/>
+          <p:nvPr/>
+        </p:nvSpPr>
+        <p:spPr>
+          <a:xfrm>
+            <a:off x="457200" y="4114800"/>
+            <a:ext cx="8229600" cy="457200"/>
+          </a:xfrm>
+          <a:prstGeom prst="rect">
+            <a:avLst/>
+          </a:prstGeom>
+          <a:noFill/>
+          <a:ln/>
+        </p:spPr>
+        <p:txBody>
+          <a:bodyPr wrap="square" lIns="0" tIns="0" rIns="0" bIns="0" rtlCol="0" anchor="ctr"/>
+          <a:lstStyle/>
+          <a:p>
+            <a:pPr indent="0" marL="0">
+              <a:buNone/>
+            </a:pPr>
+            <a:r>
+              <a:rPr lang="en-US" sz="1600" b="1" i="1" dirty="0">
                 <a:solidFill>
                   <a:srgbClr val="F5C842"/>
                 </a:solidFill>
@@ -2576,604 +2968,9 @@
                 <a:ea typeface="Georgia" pitchFamily="34" charset="-122"/>
                 <a:cs typeface="Georgia" pitchFamily="34" charset="-120"/>
               </a:rPr>
-              <a:t>Bonus: Why are sunsets red?</a:t>
-            </a:r>
-            <a:endParaRPr lang="en-US" sz="3000" dirty="0"/>
-          </a:p>
-        </p:txBody>
-      </p:sp>
-      <p:sp>
-        <p:nvSpPr>
-          <p:cNvPr id="6" name="Text 4"/>
-          <p:cNvSpPr/>
-          <p:nvPr/>
-        </p:nvSpPr>
-        <p:spPr>
-          <a:xfrm>
-            <a:off x="457200" y="2423160"/>
-            <a:ext cx="8229600" cy="2286000"/>
-          </a:xfrm>
-          <a:prstGeom prst="rect">
-            <a:avLst/>
-          </a:prstGeom>
-          <a:noFill/>
-          <a:ln/>
-        </p:spPr>
-        <p:txBody>
-          <a:bodyPr wrap="square" lIns="0" tIns="0" rIns="0" bIns="0" rtlCol="0" anchor="ctr"/>
-          <a:lstStyle/>
-          <a:p>
-            <a:pPr indent="0" marL="0">
-              <a:buNone/>
-            </a:pPr>
-            <a:r>
-              <a:rPr lang="en-US" sz="1500" dirty="0">
-                <a:solidFill>
-                  <a:srgbClr val="FFFFFF"/>
-                </a:solidFill>
-                <a:latin typeface="Calibri" pitchFamily="34" charset="0"/>
-                <a:ea typeface="Calibri" pitchFamily="34" charset="-122"/>
-                <a:cs typeface="Calibri" pitchFamily="34" charset="-120"/>
-              </a:rPr>
-              <a:t>At sunset, sunlight travels through MUCH more atmosphere to reach your eyes.</a:t>
-            </a:r>
-            <a:endParaRPr lang="en-US" sz="1500" dirty="0"/>
-          </a:p>
-          <a:p>
-            <a:pPr indent="0" marL="0">
-              <a:buNone/>
-            </a:pPr>
-            <a:endParaRPr lang="en-US" sz="1500" dirty="0"/>
-          </a:p>
-          <a:p>
-            <a:pPr indent="0" marL="0">
-              <a:buNone/>
-            </a:pPr>
-            <a:r>
-              <a:rPr lang="en-US" sz="1500" dirty="0">
-                <a:solidFill>
-                  <a:srgbClr val="FFFFFF"/>
-                </a:solidFill>
-                <a:latin typeface="Calibri" pitchFamily="34" charset="0"/>
-                <a:ea typeface="Calibri" pitchFamily="34" charset="-122"/>
-                <a:cs typeface="Calibri" pitchFamily="34" charset="-120"/>
-              </a:rPr>
-              <a:t>All the blue light gets scattered away long before it arrives.</a:t>
-            </a:r>
-            <a:endParaRPr lang="en-US" sz="1500" dirty="0"/>
-          </a:p>
-          <a:p>
-            <a:pPr indent="0" marL="0">
-              <a:buNone/>
-            </a:pPr>
-            <a:endParaRPr lang="en-US" sz="1500" dirty="0"/>
-          </a:p>
-          <a:p>
-            <a:pPr indent="0" marL="0">
-              <a:buNone/>
-            </a:pPr>
-            <a:r>
-              <a:rPr lang="en-US" sz="1500" dirty="0">
-                <a:solidFill>
-                  <a:srgbClr val="FFFFFF"/>
-                </a:solidFill>
-                <a:latin typeface="Calibri" pitchFamily="34" charset="0"/>
-                <a:ea typeface="Calibri" pitchFamily="34" charset="-122"/>
-                <a:cs typeface="Calibri" pitchFamily="34" charset="-120"/>
-              </a:rPr>
-              <a:t>Only the long-wavelength reds and oranges make it through → stunning sunsets!</a:t>
-            </a:r>
-            <a:endParaRPr lang="en-US" sz="1500" dirty="0"/>
-          </a:p>
-        </p:txBody>
-      </p:sp>
-    </p:spTree>
-  </p:cSld>
-  <p:clrMapOvr>
-    <a:masterClrMapping/>
-  </p:clrMapOvr>
-</p:sld>
-</file>
-
-<file path=ppt/slides/slide5.xml><?xml version="1.0" encoding="utf-8"?>
-<p:sld xmlns:a="http://schemas.openxmlformats.org/drawingml/2006/main" xmlns:r="http://schemas.openxmlformats.org/officeDocument/2006/relationships" xmlns:p="http://schemas.openxmlformats.org/presentationml/2006/main">
-  <p:cSld name="Slide 5">
-    <p:bg>
-      <p:bgPr>
-        <a:solidFill>
-          <a:srgbClr val="0D3B6E"/>
-        </a:solidFill>
-      </p:bgPr>
-    </p:bg>
-    <p:spTree>
-      <p:nvGrpSpPr>
-        <p:cNvPr id="1" name=""/>
-        <p:cNvGrpSpPr/>
-        <p:nvPr/>
-      </p:nvGrpSpPr>
-      <p:grpSpPr>
-        <a:xfrm>
-          <a:off x="0" y="0"/>
-          <a:ext cx="0" cy="0"/>
-          <a:chOff x="0" y="0"/>
-          <a:chExt cx="0" cy="0"/>
-        </a:xfrm>
-      </p:grpSpPr>
-      <p:sp>
-        <p:nvSpPr>
-          <p:cNvPr id="2" name="Text 0"/>
-          <p:cNvSpPr/>
-          <p:nvPr/>
-        </p:nvSpPr>
-        <p:spPr>
-          <a:xfrm>
-            <a:off x="457200" y="320040"/>
-            <a:ext cx="8229600" cy="731520"/>
-          </a:xfrm>
-          <a:prstGeom prst="rect">
-            <a:avLst/>
-          </a:prstGeom>
-          <a:noFill/>
-          <a:ln/>
-        </p:spPr>
-        <p:txBody>
-          <a:bodyPr wrap="square" lIns="0" tIns="0" rIns="0" bIns="0" rtlCol="0" anchor="ctr"/>
-          <a:lstStyle/>
-          <a:p>
-            <a:pPr indent="0" marL="0">
-              <a:buNone/>
-            </a:pPr>
-            <a:r>
-              <a:rPr lang="en-US" sz="3600" b="1" dirty="0">
-                <a:solidFill>
-                  <a:srgbClr val="F5C842"/>
-                </a:solidFill>
-                <a:latin typeface="Georgia" pitchFamily="34" charset="0"/>
-                <a:ea typeface="Georgia" pitchFamily="34" charset="-122"/>
-                <a:cs typeface="Georgia" pitchFamily="34" charset="-120"/>
-              </a:rPr>
-              <a:t>So... why IS the sky blue?</a:t>
-            </a:r>
-            <a:endParaRPr lang="en-US" sz="3600" dirty="0"/>
-          </a:p>
-        </p:txBody>
-      </p:sp>
-      <p:sp>
-        <p:nvSpPr>
-          <p:cNvPr id="3" name="Shape 1"/>
-          <p:cNvSpPr/>
-          <p:nvPr/>
-        </p:nvSpPr>
-        <p:spPr>
-          <a:xfrm>
-            <a:off x="365760" y="1234440"/>
-            <a:ext cx="594360" cy="594360"/>
-          </a:xfrm>
-          <a:prstGeom prst="ellipse">
-            <a:avLst/>
-          </a:prstGeom>
-          <a:solidFill>
-            <a:srgbClr val="1A78C2"/>
-          </a:solidFill>
-          <a:ln w="12700">
-            <a:solidFill>
-              <a:srgbClr val="1A78C2"/>
-            </a:solidFill>
-            <a:prstDash val="solid"/>
-          </a:ln>
-        </p:spPr>
-      </p:sp>
-      <p:sp>
-        <p:nvSpPr>
-          <p:cNvPr id="4" name="Text 2"/>
-          <p:cNvSpPr/>
-          <p:nvPr/>
-        </p:nvSpPr>
-        <p:spPr>
-          <a:xfrm>
-            <a:off x="365760" y="1234440"/>
-            <a:ext cx="594360" cy="594360"/>
-          </a:xfrm>
-          <a:prstGeom prst="rect">
-            <a:avLst/>
-          </a:prstGeom>
-          <a:noFill/>
-          <a:ln/>
-        </p:spPr>
-        <p:txBody>
-          <a:bodyPr wrap="square" lIns="0" tIns="0" rIns="0" bIns="0" rtlCol="0" anchor="ctr"/>
-          <a:lstStyle/>
-          <a:p>
-            <a:pPr algn="ctr" indent="0" marL="0">
-              <a:buNone/>
-            </a:pPr>
-            <a:r>
-              <a:rPr lang="en-US" sz="1800" dirty="0">
-                <a:solidFill>
-                  <a:srgbClr val="000000"/>
-                </a:solidFill>
-              </a:rPr>
-              <a:t>☀️</a:t>
-            </a:r>
-            <a:endParaRPr lang="en-US" sz="1800" dirty="0"/>
-          </a:p>
-        </p:txBody>
-      </p:sp>
-      <p:sp>
-        <p:nvSpPr>
-          <p:cNvPr id="5" name="Text 3"/>
-          <p:cNvSpPr/>
-          <p:nvPr/>
-        </p:nvSpPr>
-        <p:spPr>
-          <a:xfrm>
-            <a:off x="1143000" y="1280160"/>
-            <a:ext cx="7315200" cy="502920"/>
-          </a:xfrm>
-          <a:prstGeom prst="rect">
-            <a:avLst/>
-          </a:prstGeom>
-          <a:noFill/>
-          <a:ln/>
-        </p:spPr>
-        <p:txBody>
-          <a:bodyPr wrap="square" lIns="0" tIns="0" rIns="0" bIns="0" rtlCol="0" anchor="ctr"/>
-          <a:lstStyle/>
-          <a:p>
-            <a:pPr indent="0" marL="0">
-              <a:buNone/>
-            </a:pPr>
-            <a:r>
-              <a:rPr lang="en-US" sz="1800" dirty="0">
-                <a:solidFill>
-                  <a:srgbClr val="FFFFFF"/>
-                </a:solidFill>
-                <a:latin typeface="Calibri" pitchFamily="34" charset="0"/>
-                <a:ea typeface="Calibri" pitchFamily="34" charset="-122"/>
-                <a:cs typeface="Calibri" pitchFamily="34" charset="-120"/>
-              </a:rPr>
-              <a:t>Sunlight carries all colors</a:t>
-            </a:r>
-            <a:endParaRPr lang="en-US" sz="1800" dirty="0"/>
-          </a:p>
-        </p:txBody>
-      </p:sp>
-      <p:sp>
-        <p:nvSpPr>
-          <p:cNvPr id="6" name="Shape 4"/>
-          <p:cNvSpPr/>
-          <p:nvPr/>
-        </p:nvSpPr>
-        <p:spPr>
-          <a:xfrm>
-            <a:off x="365760" y="2075688"/>
-            <a:ext cx="594360" cy="594360"/>
-          </a:xfrm>
-          <a:prstGeom prst="ellipse">
-            <a:avLst/>
-          </a:prstGeom>
-          <a:solidFill>
-            <a:srgbClr val="1A78C2"/>
-          </a:solidFill>
-          <a:ln w="12700">
-            <a:solidFill>
-              <a:srgbClr val="1A78C2"/>
-            </a:solidFill>
-            <a:prstDash val="solid"/>
-          </a:ln>
-        </p:spPr>
-      </p:sp>
-      <p:sp>
-        <p:nvSpPr>
-          <p:cNvPr id="7" name="Text 5"/>
-          <p:cNvSpPr/>
-          <p:nvPr/>
-        </p:nvSpPr>
-        <p:spPr>
-          <a:xfrm>
-            <a:off x="365760" y="2075688"/>
-            <a:ext cx="594360" cy="594360"/>
-          </a:xfrm>
-          <a:prstGeom prst="rect">
-            <a:avLst/>
-          </a:prstGeom>
-          <a:noFill/>
-          <a:ln/>
-        </p:spPr>
-        <p:txBody>
-          <a:bodyPr wrap="square" lIns="0" tIns="0" rIns="0" bIns="0" rtlCol="0" anchor="ctr"/>
-          <a:lstStyle/>
-          <a:p>
-            <a:pPr algn="ctr" indent="0" marL="0">
-              <a:buNone/>
-            </a:pPr>
-            <a:r>
-              <a:rPr lang="en-US" sz="1800" dirty="0">
-                <a:solidFill>
-                  <a:srgbClr val="000000"/>
-                </a:solidFill>
-              </a:rPr>
-              <a:t>💨</a:t>
-            </a:r>
-            <a:endParaRPr lang="en-US" sz="1800" dirty="0"/>
-          </a:p>
-        </p:txBody>
-      </p:sp>
-      <p:sp>
-        <p:nvSpPr>
-          <p:cNvPr id="8" name="Text 6"/>
-          <p:cNvSpPr/>
-          <p:nvPr/>
-        </p:nvSpPr>
-        <p:spPr>
-          <a:xfrm>
-            <a:off x="1143000" y="2121408"/>
-            <a:ext cx="7315200" cy="502920"/>
-          </a:xfrm>
-          <a:prstGeom prst="rect">
-            <a:avLst/>
-          </a:prstGeom>
-          <a:noFill/>
-          <a:ln/>
-        </p:spPr>
-        <p:txBody>
-          <a:bodyPr wrap="square" lIns="0" tIns="0" rIns="0" bIns="0" rtlCol="0" anchor="ctr"/>
-          <a:lstStyle/>
-          <a:p>
-            <a:pPr indent="0" marL="0">
-              <a:buNone/>
-            </a:pPr>
-            <a:r>
-              <a:rPr lang="en-US" sz="1800" dirty="0">
-                <a:solidFill>
-                  <a:srgbClr val="FFFFFF"/>
-                </a:solidFill>
-                <a:latin typeface="Calibri" pitchFamily="34" charset="0"/>
-                <a:ea typeface="Calibri" pitchFamily="34" charset="-122"/>
-                <a:cs typeface="Calibri" pitchFamily="34" charset="-120"/>
-              </a:rPr>
-              <a:t>Atmosphere scatters short wavelengths most</a:t>
-            </a:r>
-            <a:endParaRPr lang="en-US" sz="1800" dirty="0"/>
-          </a:p>
-        </p:txBody>
-      </p:sp>
-      <p:sp>
-        <p:nvSpPr>
-          <p:cNvPr id="9" name="Shape 7"/>
-          <p:cNvSpPr/>
-          <p:nvPr/>
-        </p:nvSpPr>
-        <p:spPr>
-          <a:xfrm>
-            <a:off x="365760" y="2916936"/>
-            <a:ext cx="594360" cy="594360"/>
-          </a:xfrm>
-          <a:prstGeom prst="ellipse">
-            <a:avLst/>
-          </a:prstGeom>
-          <a:solidFill>
-            <a:srgbClr val="1A78C2"/>
-          </a:solidFill>
-          <a:ln w="12700">
-            <a:solidFill>
-              <a:srgbClr val="1A78C2"/>
-            </a:solidFill>
-            <a:prstDash val="solid"/>
-          </a:ln>
-        </p:spPr>
-      </p:sp>
-      <p:sp>
-        <p:nvSpPr>
-          <p:cNvPr id="10" name="Text 8"/>
-          <p:cNvSpPr/>
-          <p:nvPr/>
-        </p:nvSpPr>
-        <p:spPr>
-          <a:xfrm>
-            <a:off x="365760" y="2916936"/>
-            <a:ext cx="594360" cy="594360"/>
-          </a:xfrm>
-          <a:prstGeom prst="rect">
-            <a:avLst/>
-          </a:prstGeom>
-          <a:noFill/>
-          <a:ln/>
-        </p:spPr>
-        <p:txBody>
-          <a:bodyPr wrap="square" lIns="0" tIns="0" rIns="0" bIns="0" rtlCol="0" anchor="ctr"/>
-          <a:lstStyle/>
-          <a:p>
-            <a:pPr algn="ctr" indent="0" marL="0">
-              <a:buNone/>
-            </a:pPr>
-            <a:r>
-              <a:rPr lang="en-US" sz="1800" dirty="0">
-                <a:solidFill>
-                  <a:srgbClr val="000000"/>
-                </a:solidFill>
-              </a:rPr>
-              <a:t>🔵</a:t>
-            </a:r>
-            <a:endParaRPr lang="en-US" sz="1800" dirty="0"/>
-          </a:p>
-        </p:txBody>
-      </p:sp>
-      <p:sp>
-        <p:nvSpPr>
-          <p:cNvPr id="11" name="Text 9"/>
-          <p:cNvSpPr/>
-          <p:nvPr/>
-        </p:nvSpPr>
-        <p:spPr>
-          <a:xfrm>
-            <a:off x="1143000" y="2962656"/>
-            <a:ext cx="7315200" cy="502920"/>
-          </a:xfrm>
-          <a:prstGeom prst="rect">
-            <a:avLst/>
-          </a:prstGeom>
-          <a:noFill/>
-          <a:ln/>
-        </p:spPr>
-        <p:txBody>
-          <a:bodyPr wrap="square" lIns="0" tIns="0" rIns="0" bIns="0" rtlCol="0" anchor="ctr"/>
-          <a:lstStyle/>
-          <a:p>
-            <a:pPr indent="0" marL="0">
-              <a:buNone/>
-            </a:pPr>
-            <a:r>
-              <a:rPr lang="en-US" sz="1800" dirty="0">
-                <a:solidFill>
-                  <a:srgbClr val="FFFFFF"/>
-                </a:solidFill>
-                <a:latin typeface="Calibri" pitchFamily="34" charset="0"/>
-                <a:ea typeface="Calibri" pitchFamily="34" charset="-122"/>
-                <a:cs typeface="Calibri" pitchFamily="34" charset="-120"/>
-              </a:rPr>
-              <a:t>Blue scatters in every direction → fills the sky</a:t>
-            </a:r>
-            <a:endParaRPr lang="en-US" sz="1800" dirty="0"/>
-          </a:p>
-        </p:txBody>
-      </p:sp>
-      <p:sp>
-        <p:nvSpPr>
-          <p:cNvPr id="12" name="Shape 10"/>
-          <p:cNvSpPr/>
-          <p:nvPr/>
-        </p:nvSpPr>
-        <p:spPr>
-          <a:xfrm>
-            <a:off x="365760" y="3758184"/>
-            <a:ext cx="594360" cy="594360"/>
-          </a:xfrm>
-          <a:prstGeom prst="ellipse">
-            <a:avLst/>
-          </a:prstGeom>
-          <a:solidFill>
-            <a:srgbClr val="1A78C2"/>
-          </a:solidFill>
-          <a:ln w="12700">
-            <a:solidFill>
-              <a:srgbClr val="1A78C2"/>
-            </a:solidFill>
-            <a:prstDash val="solid"/>
-          </a:ln>
-        </p:spPr>
-      </p:sp>
-      <p:sp>
-        <p:nvSpPr>
-          <p:cNvPr id="13" name="Text 11"/>
-          <p:cNvSpPr/>
-          <p:nvPr/>
-        </p:nvSpPr>
-        <p:spPr>
-          <a:xfrm>
-            <a:off x="365760" y="3758184"/>
-            <a:ext cx="594360" cy="594360"/>
-          </a:xfrm>
-          <a:prstGeom prst="rect">
-            <a:avLst/>
-          </a:prstGeom>
-          <a:noFill/>
-          <a:ln/>
-        </p:spPr>
-        <p:txBody>
-          <a:bodyPr wrap="square" lIns="0" tIns="0" rIns="0" bIns="0" rtlCol="0" anchor="ctr"/>
-          <a:lstStyle/>
-          <a:p>
-            <a:pPr algn="ctr" indent="0" marL="0">
-              <a:buNone/>
-            </a:pPr>
-            <a:r>
-              <a:rPr lang="en-US" sz="1800" dirty="0">
-                <a:solidFill>
-                  <a:srgbClr val="000000"/>
-                </a:solidFill>
-              </a:rPr>
-              <a:t>🌅</a:t>
-            </a:r>
-            <a:endParaRPr lang="en-US" sz="1800" dirty="0"/>
-          </a:p>
-        </p:txBody>
-      </p:sp>
-      <p:sp>
-        <p:nvSpPr>
-          <p:cNvPr id="14" name="Text 12"/>
-          <p:cNvSpPr/>
-          <p:nvPr/>
-        </p:nvSpPr>
-        <p:spPr>
-          <a:xfrm>
-            <a:off x="1143000" y="3803904"/>
-            <a:ext cx="7315200" cy="502920"/>
-          </a:xfrm>
-          <a:prstGeom prst="rect">
-            <a:avLst/>
-          </a:prstGeom>
-          <a:noFill/>
-          <a:ln/>
-        </p:spPr>
-        <p:txBody>
-          <a:bodyPr wrap="square" lIns="0" tIns="0" rIns="0" bIns="0" rtlCol="0" anchor="ctr"/>
-          <a:lstStyle/>
-          <a:p>
-            <a:pPr indent="0" marL="0">
-              <a:buNone/>
-            </a:pPr>
-            <a:r>
-              <a:rPr lang="en-US" sz="1800" dirty="0">
-                <a:solidFill>
-                  <a:srgbClr val="FFFFFF"/>
-                </a:solidFill>
-                <a:latin typeface="Calibri" pitchFamily="34" charset="0"/>
-                <a:ea typeface="Calibri" pitchFamily="34" charset="-122"/>
-                <a:cs typeface="Calibri" pitchFamily="34" charset="-120"/>
-              </a:rPr>
-              <a:t>At sunset, only red/orange survive the longer path</a:t>
-            </a:r>
-            <a:endParaRPr lang="en-US" sz="1800" dirty="0"/>
-          </a:p>
-        </p:txBody>
-      </p:sp>
-      <p:sp>
-        <p:nvSpPr>
-          <p:cNvPr id="15" name="Text 13"/>
-          <p:cNvSpPr/>
-          <p:nvPr/>
-        </p:nvSpPr>
-        <p:spPr>
-          <a:xfrm>
-            <a:off x="457200" y="4572000"/>
-            <a:ext cx="8229600" cy="365760"/>
-          </a:xfrm>
-          <a:prstGeom prst="rect">
-            <a:avLst/>
-          </a:prstGeom>
-          <a:noFill/>
-          <a:ln/>
-        </p:spPr>
-        <p:txBody>
-          <a:bodyPr wrap="square" lIns="0" tIns="0" rIns="0" bIns="0" rtlCol="0" anchor="ctr"/>
-          <a:lstStyle/>
-          <a:p>
-            <a:pPr indent="0" marL="0">
-              <a:buNone/>
-            </a:pPr>
-            <a:r>
-              <a:rPr lang="en-US" sz="1400" i="1" dirty="0">
-                <a:solidFill>
-                  <a:srgbClr val="F5C842"/>
-                </a:solidFill>
-                <a:latin typeface="Calibri" pitchFamily="34" charset="0"/>
-                <a:ea typeface="Calibri" pitchFamily="34" charset="-122"/>
-                <a:cs typeface="Calibri" pitchFamily="34" charset="-120"/>
-              </a:rPr>
-              <a:t>It's not magic — it's physics. Pretty cool, right?</a:t>
-            </a:r>
-            <a:endParaRPr lang="en-US" sz="1400" dirty="0"/>
+              <a:t>Same physics. Longer path. Different color.</a:t>
+            </a:r>
+            <a:endParaRPr lang="en-US" sz="1600" dirty="0"/>
           </a:p>
         </p:txBody>
       </p:sp>

</xml_diff>

<commit_message>
Delete slide 3 (scattering diagram)
</commit_message>
<xml_diff>
--- a/WhyIsSkyBlue.pptx
+++ b/WhyIsSkyBlue.pptx
@@ -8,10 +8,9 @@
     <p:sldId id="256" r:id="rId2"/>
     <p:sldId id="257" r:id="rId3"/>
     <p:sldId id="258" r:id="rId4"/>
-    <p:sldId id="259" r:id="rId5"/>
   </p:sldIdLst>
   <p:notesMasterIdLst>
-    <p:notesMasterId r:id="rId6"/>
+    <p:notesMasterId r:id="rId5"/>
   </p:notesMasterIdLst>
   <p:sldSz cx="9144000" cy="5143500"/>
   <p:notesSz cx="5143500" cy="9144000"/>
@@ -723,94 +722,6 @@
 </p:notes>
 </file>
 
-<file path=ppt/notesSlides/notesSlide4.xml><?xml version="1.0" encoding="utf-8"?>
-<p:notes xmlns:a="http://schemas.openxmlformats.org/drawingml/2006/main" xmlns:r="http://schemas.openxmlformats.org/officeDocument/2006/relationships" xmlns:p="http://schemas.openxmlformats.org/presentationml/2006/main">
-  <p:cSld>
-    <p:spTree>
-      <p:nvGrpSpPr>
-        <p:cNvPr id="1" name=""/>
-        <p:cNvGrpSpPr/>
-        <p:nvPr/>
-      </p:nvGrpSpPr>
-      <p:grpSpPr>
-        <a:xfrm>
-          <a:off x="0" y="0"/>
-          <a:ext cx="0" cy="0"/>
-          <a:chOff x="0" y="0"/>
-          <a:chExt cx="0" cy="0"/>
-        </a:xfrm>
-      </p:grpSpPr>
-      <p:sp>
-        <p:nvSpPr>
-          <p:cNvPr id="2" name="Slide Image Placeholder 1"/>
-          <p:cNvSpPr>
-            <a:spLocks noGrp="1" noRot="1" noChangeAspect="1"/>
-          </p:cNvSpPr>
-          <p:nvPr>
-            <p:ph type="sldImg"/>
-          </p:nvPr>
-        </p:nvSpPr>
-        <p:spPr/>
-      </p:sp>
-      <p:sp>
-        <p:nvSpPr>
-          <p:cNvPr id="3" name="Notes Placeholder 2"/>
-          <p:cNvSpPr>
-            <a:spLocks noGrp="1"/>
-          </p:cNvSpPr>
-          <p:nvPr>
-            <p:ph type="body" idx="1"/>
-          </p:nvPr>
-        </p:nvSpPr>
-        <p:spPr/>
-        <p:txBody>
-          <a:bodyPr/>
-          <a:lstStyle/>
-          <a:p>
-            <a:r>
-              <a:rPr lang="en-US" dirty="0"/>
-              <a:t/>
-            </a:r>
-            <a:endParaRPr lang="en-US" dirty="0"/>
-          </a:p>
-        </p:txBody>
-      </p:sp>
-      <p:sp>
-        <p:nvSpPr>
-          <p:cNvPr id="4" name="Slide Number Placeholder 3"/>
-          <p:cNvSpPr>
-            <a:spLocks noGrp="1"/>
-          </p:cNvSpPr>
-          <p:nvPr>
-            <p:ph type="sldNum" sz="quarter" idx="10"/>
-          </p:nvPr>
-        </p:nvSpPr>
-        <p:spPr/>
-        <p:txBody>
-          <a:bodyPr/>
-          <a:lstStyle/>
-          <a:p>
-            <a:fld id="{F7021451-1387-4CA6-816F-3879F97B5CBC}" type="slidenum">
-              <a:rPr lang="en-US"/>
-              <a:t>4</a:t>
-            </a:fld>
-            <a:endParaRPr lang="en-US"/>
-          </a:p>
-        </p:txBody>
-      </p:sp>
-    </p:spTree>
-    <p:extLst>
-      <p:ext uri="{BB962C8B-B14F-4D97-AF65-F5344CB8AC3E}">
-        <p14:creationId xmlns:p14="http://schemas.microsoft.com/office/powerpoint/2010/main" val="1024086991"/>
-      </p:ext>
-    </p:extLst>
-  </p:cSld>
-  <p:clrMapOvr>
-    <a:masterClrMapping/>
-  </p:clrMapOvr>
-</p:notes>
-</file>
-
 <file path=ppt/slideLayouts/slideLayout1.xml><?xml version="1.0" encoding="utf-8"?>
 <p:sldLayout xmlns:a="http://schemas.openxmlformats.org/drawingml/2006/main" xmlns:r="http://schemas.openxmlformats.org/officeDocument/2006/relationships" xmlns:p="http://schemas.openxmlformats.org/presentationml/2006/main" preserve="1">
   <p:cSld name="DEFAULT">
@@ -2146,587 +2057,6 @@
 <file path=ppt/slides/slide3.xml><?xml version="1.0" encoding="utf-8"?>
 <p:sld xmlns:a="http://schemas.openxmlformats.org/drawingml/2006/main" xmlns:r="http://schemas.openxmlformats.org/officeDocument/2006/relationships" xmlns:p="http://schemas.openxmlformats.org/presentationml/2006/main">
   <p:cSld name="Slide 3">
-    <p:bg>
-      <p:bgPr>
-        <a:solidFill>
-          <a:srgbClr val="F0F4F8"/>
-        </a:solidFill>
-      </p:bgPr>
-    </p:bg>
-    <p:spTree>
-      <p:nvGrpSpPr>
-        <p:cNvPr id="1" name=""/>
-        <p:cNvGrpSpPr/>
-        <p:nvPr/>
-      </p:nvGrpSpPr>
-      <p:grpSpPr>
-        <a:xfrm>
-          <a:off x="0" y="0"/>
-          <a:ext cx="0" cy="0"/>
-          <a:chOff x="0" y="0"/>
-          <a:chExt cx="0" cy="0"/>
-        </a:xfrm>
-      </p:grpSpPr>
-      <p:sp>
-        <p:nvSpPr>
-          <p:cNvPr id="2" name="Text 0"/>
-          <p:cNvSpPr/>
-          <p:nvPr/>
-        </p:nvSpPr>
-        <p:spPr>
-          <a:xfrm>
-            <a:off x="457200" y="228600"/>
-            <a:ext cx="8229600" cy="640080"/>
-          </a:xfrm>
-          <a:prstGeom prst="rect">
-            <a:avLst/>
-          </a:prstGeom>
-          <a:noFill/>
-          <a:ln/>
-        </p:spPr>
-        <p:txBody>
-          <a:bodyPr wrap="square" lIns="0" tIns="0" rIns="0" bIns="0" rtlCol="0" anchor="ctr"/>
-          <a:lstStyle/>
-          <a:p>
-            <a:pPr indent="0" marL="0">
-              <a:buNone/>
-            </a:pPr>
-            <a:r>
-              <a:rPr lang="en-US" sz="2800" b="1" dirty="0">
-                <a:solidFill>
-                  <a:srgbClr val="0D3B6E"/>
-                </a:solidFill>
-                <a:latin typeface="Georgia" pitchFamily="34" charset="0"/>
-                <a:ea typeface="Georgia" pitchFamily="34" charset="-122"/>
-                <a:cs typeface="Georgia" pitchFamily="34" charset="-120"/>
-              </a:rPr>
-              <a:t>Short wavelengths scatter more</a:t>
-            </a:r>
-            <a:endParaRPr lang="en-US" sz="2800" dirty="0"/>
-          </a:p>
-        </p:txBody>
-      </p:sp>
-      <p:sp>
-        <p:nvSpPr>
-          <p:cNvPr id="3" name="Shape 1"/>
-          <p:cNvSpPr/>
-          <p:nvPr/>
-        </p:nvSpPr>
-        <p:spPr>
-          <a:xfrm>
-            <a:off x="274320" y="1188720"/>
-            <a:ext cx="914400" cy="914400"/>
-          </a:xfrm>
-          <a:prstGeom prst="ellipse">
-            <a:avLst/>
-          </a:prstGeom>
-          <a:solidFill>
-            <a:srgbClr val="F5C842"/>
-          </a:solidFill>
-          <a:ln w="12700">
-            <a:solidFill>
-              <a:srgbClr val="F5C842"/>
-            </a:solidFill>
-            <a:prstDash val="solid"/>
-          </a:ln>
-        </p:spPr>
-      </p:sp>
-      <p:sp>
-        <p:nvSpPr>
-          <p:cNvPr id="4" name="Text 2"/>
-          <p:cNvSpPr/>
-          <p:nvPr/>
-        </p:nvSpPr>
-        <p:spPr>
-          <a:xfrm>
-            <a:off x="274320" y="1188720"/>
-            <a:ext cx="914400" cy="914400"/>
-          </a:xfrm>
-          <a:prstGeom prst="rect">
-            <a:avLst/>
-          </a:prstGeom>
-          <a:noFill/>
-          <a:ln/>
-        </p:spPr>
-        <p:txBody>
-          <a:bodyPr wrap="square" lIns="0" tIns="0" rIns="0" bIns="0" rtlCol="0" anchor="ctr"/>
-          <a:lstStyle/>
-          <a:p>
-            <a:pPr algn="ctr" indent="0" marL="0">
-              <a:buNone/>
-            </a:pPr>
-            <a:r>
-              <a:rPr lang="en-US" sz="1000" b="1" dirty="0">
-                <a:solidFill>
-                  <a:srgbClr val="0D3B6E"/>
-                </a:solidFill>
-              </a:rPr>
-              <a:t>SUN</a:t>
-            </a:r>
-            <a:endParaRPr lang="en-US" sz="1000" dirty="0"/>
-          </a:p>
-        </p:txBody>
-      </p:sp>
-      <p:sp>
-        <p:nvSpPr>
-          <p:cNvPr id="5" name="Shape 3"/>
-          <p:cNvSpPr/>
-          <p:nvPr/>
-        </p:nvSpPr>
-        <p:spPr>
-          <a:xfrm>
-            <a:off x="1234440" y="1645920"/>
-            <a:ext cx="1371600" cy="0"/>
-          </a:xfrm>
-          <a:prstGeom prst="line">
-            <a:avLst/>
-          </a:prstGeom>
-          <a:noFill/>
-          <a:ln w="38100">
-            <a:solidFill>
-              <a:srgbClr val="AAAAAA"/>
-            </a:solidFill>
-            <a:prstDash val="solid"/>
-          </a:ln>
-        </p:spPr>
-      </p:sp>
-      <p:sp>
-        <p:nvSpPr>
-          <p:cNvPr id="6" name="Shape 4"/>
-          <p:cNvSpPr/>
-          <p:nvPr/>
-        </p:nvSpPr>
-        <p:spPr>
-          <a:xfrm>
-            <a:off x="2651760" y="1234440"/>
-            <a:ext cx="1371600" cy="822960"/>
-          </a:xfrm>
-          <a:prstGeom prst="ellipse">
-            <a:avLst/>
-          </a:prstGeom>
-          <a:solidFill>
-            <a:srgbClr val="D0E8FF"/>
-          </a:solidFill>
-          <a:ln w="25400">
-            <a:solidFill>
-              <a:srgbClr val="1A78C2"/>
-            </a:solidFill>
-            <a:prstDash val="solid"/>
-          </a:ln>
-        </p:spPr>
-      </p:sp>
-      <p:sp>
-        <p:nvSpPr>
-          <p:cNvPr id="7" name="Text 5"/>
-          <p:cNvSpPr/>
-          <p:nvPr/>
-        </p:nvSpPr>
-        <p:spPr>
-          <a:xfrm>
-            <a:off x="2651760" y="1234440"/>
-            <a:ext cx="1371600" cy="822960"/>
-          </a:xfrm>
-          <a:prstGeom prst="rect">
-            <a:avLst/>
-          </a:prstGeom>
-          <a:noFill/>
-          <a:ln/>
-        </p:spPr>
-        <p:txBody>
-          <a:bodyPr wrap="square" lIns="0" tIns="0" rIns="0" bIns="0" rtlCol="0" anchor="ctr"/>
-          <a:lstStyle/>
-          <a:p>
-            <a:pPr algn="ctr" indent="0" marL="0">
-              <a:buNone/>
-            </a:pPr>
-            <a:r>
-              <a:rPr lang="en-US" sz="900" dirty="0">
-                <a:solidFill>
-                  <a:srgbClr val="0D3B6E"/>
-                </a:solidFill>
-              </a:rPr>
-              <a:t>atmosphere</a:t>
-            </a:r>
-            <a:endParaRPr lang="en-US" sz="900" dirty="0"/>
-          </a:p>
-          <a:p>
-            <a:pPr algn="ctr" indent="0" marL="0">
-              <a:buNone/>
-            </a:pPr>
-            <a:r>
-              <a:rPr lang="en-US" sz="900" dirty="0">
-                <a:solidFill>
-                  <a:srgbClr val="0D3B6E"/>
-                </a:solidFill>
-              </a:rPr>
-              <a:t>molecule</a:t>
-            </a:r>
-            <a:endParaRPr lang="en-US" sz="900" dirty="0"/>
-          </a:p>
-        </p:txBody>
-      </p:sp>
-      <p:sp>
-        <p:nvSpPr>
-          <p:cNvPr id="8" name="Shape 6"/>
-          <p:cNvSpPr/>
-          <p:nvPr/>
-        </p:nvSpPr>
-        <p:spPr>
-          <a:xfrm>
-            <a:off x="3337560" y="1234440"/>
-            <a:ext cx="0" cy="-822960"/>
-          </a:xfrm>
-          <a:prstGeom prst="line">
-            <a:avLst/>
-          </a:prstGeom>
-          <a:noFill/>
-          <a:ln w="38100">
-            <a:solidFill>
-              <a:srgbClr val="3B4FE0"/>
-            </a:solidFill>
-            <a:prstDash val="solid"/>
-          </a:ln>
-        </p:spPr>
-      </p:sp>
-      <p:sp>
-        <p:nvSpPr>
-          <p:cNvPr id="9" name="Shape 7"/>
-          <p:cNvSpPr/>
-          <p:nvPr/>
-        </p:nvSpPr>
-        <p:spPr>
-          <a:xfrm>
-            <a:off x="3337560" y="2057400"/>
-            <a:ext cx="0" cy="822960"/>
-          </a:xfrm>
-          <a:prstGeom prst="line">
-            <a:avLst/>
-          </a:prstGeom>
-          <a:noFill/>
-          <a:ln w="38100">
-            <a:solidFill>
-              <a:srgbClr val="3B4FE0"/>
-            </a:solidFill>
-            <a:prstDash val="solid"/>
-          </a:ln>
-        </p:spPr>
-      </p:sp>
-      <p:sp>
-        <p:nvSpPr>
-          <p:cNvPr id="10" name="Text 8"/>
-          <p:cNvSpPr/>
-          <p:nvPr/>
-        </p:nvSpPr>
-        <p:spPr>
-          <a:xfrm>
-            <a:off x="2468880" y="2971800"/>
-            <a:ext cx="2286000" cy="731520"/>
-          </a:xfrm>
-          <a:prstGeom prst="rect">
-            <a:avLst/>
-          </a:prstGeom>
-          <a:noFill/>
-          <a:ln/>
-        </p:spPr>
-        <p:txBody>
-          <a:bodyPr wrap="square" lIns="0" tIns="0" rIns="0" bIns="0" rtlCol="0" anchor="ctr"/>
-          <a:lstStyle/>
-          <a:p>
-            <a:pPr algn="ctr" indent="0" marL="0">
-              <a:buNone/>
-            </a:pPr>
-            <a:r>
-              <a:rPr lang="en-US" sz="1200" b="1" dirty="0">
-                <a:solidFill>
-                  <a:srgbClr val="3B4FE0"/>
-                </a:solidFill>
-                <a:latin typeface="Calibri" pitchFamily="34" charset="0"/>
-                <a:ea typeface="Calibri" pitchFamily="34" charset="-122"/>
-                <a:cs typeface="Calibri" pitchFamily="34" charset="-120"/>
-              </a:rPr>
-              <a:t>Blue (450 nm)</a:t>
-            </a:r>
-            <a:endParaRPr lang="en-US" sz="1200" dirty="0"/>
-          </a:p>
-          <a:p>
-            <a:pPr algn="ctr" indent="0" marL="0">
-              <a:buNone/>
-            </a:pPr>
-            <a:r>
-              <a:rPr lang="en-US" sz="1200" b="1" dirty="0">
-                <a:solidFill>
-                  <a:srgbClr val="3B4FE0"/>
-                </a:solidFill>
-                <a:latin typeface="Calibri" pitchFamily="34" charset="0"/>
-                <a:ea typeface="Calibri" pitchFamily="34" charset="-122"/>
-                <a:cs typeface="Calibri" pitchFamily="34" charset="-120"/>
-              </a:rPr>
-              <a:t>scatters away →</a:t>
-            </a:r>
-            <a:endParaRPr lang="en-US" sz="1200" dirty="0"/>
-          </a:p>
-          <a:p>
-            <a:pPr algn="ctr" indent="0" marL="0">
-              <a:buNone/>
-            </a:pPr>
-            <a:r>
-              <a:rPr lang="en-US" sz="1200" b="1" dirty="0">
-                <a:solidFill>
-                  <a:srgbClr val="3B4FE0"/>
-                </a:solidFill>
-                <a:latin typeface="Calibri" pitchFamily="34" charset="0"/>
-                <a:ea typeface="Calibri" pitchFamily="34" charset="-122"/>
-                <a:cs typeface="Calibri" pitchFamily="34" charset="-120"/>
-              </a:rPr>
-              <a:t>fills the whole sky</a:t>
-            </a:r>
-            <a:endParaRPr lang="en-US" sz="1200" dirty="0"/>
-          </a:p>
-        </p:txBody>
-      </p:sp>
-      <p:sp>
-        <p:nvSpPr>
-          <p:cNvPr id="11" name="Shape 9"/>
-          <p:cNvSpPr/>
-          <p:nvPr/>
-        </p:nvSpPr>
-        <p:spPr>
-          <a:xfrm>
-            <a:off x="4069080" y="1645920"/>
-            <a:ext cx="2560320" cy="0"/>
-          </a:xfrm>
-          <a:prstGeom prst="line">
-            <a:avLst/>
-          </a:prstGeom>
-          <a:noFill/>
-          <a:ln w="38100">
-            <a:solidFill>
-              <a:srgbClr val="E8000D"/>
-            </a:solidFill>
-            <a:prstDash val="solid"/>
-          </a:ln>
-        </p:spPr>
-      </p:sp>
-      <p:sp>
-        <p:nvSpPr>
-          <p:cNvPr id="12" name="Text 10"/>
-          <p:cNvSpPr/>
-          <p:nvPr/>
-        </p:nvSpPr>
-        <p:spPr>
-          <a:xfrm>
-            <a:off x="4663440" y="777240"/>
-            <a:ext cx="2286000" cy="411480"/>
-          </a:xfrm>
-          <a:prstGeom prst="rect">
-            <a:avLst/>
-          </a:prstGeom>
-          <a:noFill/>
-          <a:ln/>
-        </p:spPr>
-        <p:txBody>
-          <a:bodyPr wrap="square" lIns="0" tIns="0" rIns="0" bIns="0" rtlCol="0" anchor="ctr"/>
-          <a:lstStyle/>
-          <a:p>
-            <a:pPr algn="ctr" indent="0" marL="0">
-              <a:buNone/>
-            </a:pPr>
-            <a:r>
-              <a:rPr lang="en-US" sz="1200" b="1" dirty="0">
-                <a:solidFill>
-                  <a:srgbClr val="E8000D"/>
-                </a:solidFill>
-                <a:latin typeface="Calibri" pitchFamily="34" charset="0"/>
-                <a:ea typeface="Calibri" pitchFamily="34" charset="-122"/>
-                <a:cs typeface="Calibri" pitchFamily="34" charset="-120"/>
-              </a:rPr>
-              <a:t>Red (700 nm)</a:t>
-            </a:r>
-            <a:endParaRPr lang="en-US" sz="1200" dirty="0"/>
-          </a:p>
-          <a:p>
-            <a:pPr algn="ctr" indent="0" marL="0">
-              <a:buNone/>
-            </a:pPr>
-            <a:r>
-              <a:rPr lang="en-US" sz="1200" b="1" dirty="0">
-                <a:solidFill>
-                  <a:srgbClr val="E8000D"/>
-                </a:solidFill>
-                <a:latin typeface="Calibri" pitchFamily="34" charset="0"/>
-                <a:ea typeface="Calibri" pitchFamily="34" charset="-122"/>
-                <a:cs typeface="Calibri" pitchFamily="34" charset="-120"/>
-              </a:rPr>
-              <a:t>passes straight through</a:t>
-            </a:r>
-            <a:endParaRPr lang="en-US" sz="1200" dirty="0"/>
-          </a:p>
-        </p:txBody>
-      </p:sp>
-      <p:sp>
-        <p:nvSpPr>
-          <p:cNvPr id="13" name="Shape 11"/>
-          <p:cNvSpPr/>
-          <p:nvPr/>
-        </p:nvSpPr>
-        <p:spPr>
-          <a:xfrm>
-            <a:off x="6766560" y="1371600"/>
-            <a:ext cx="640080" cy="548640"/>
-          </a:xfrm>
-          <a:prstGeom prst="ellipse">
-            <a:avLst/>
-          </a:prstGeom>
-          <a:solidFill>
-            <a:srgbClr val="FFFFFF"/>
-          </a:solidFill>
-          <a:ln w="12700">
-            <a:solidFill>
-              <a:srgbClr val="444444"/>
-            </a:solidFill>
-            <a:prstDash val="solid"/>
-          </a:ln>
-        </p:spPr>
-      </p:sp>
-      <p:sp>
-        <p:nvSpPr>
-          <p:cNvPr id="14" name="Shape 12"/>
-          <p:cNvSpPr/>
-          <p:nvPr/>
-        </p:nvSpPr>
-        <p:spPr>
-          <a:xfrm>
-            <a:off x="6949440" y="1481328"/>
-            <a:ext cx="274320" cy="274320"/>
-          </a:xfrm>
-          <a:prstGeom prst="ellipse">
-            <a:avLst/>
-          </a:prstGeom>
-          <a:solidFill>
-            <a:srgbClr val="0D3B6E"/>
-          </a:solidFill>
-          <a:ln w="12700">
-            <a:solidFill>
-              <a:srgbClr val="0D3B6E"/>
-            </a:solidFill>
-            <a:prstDash val="solid"/>
-          </a:ln>
-        </p:spPr>
-      </p:sp>
-      <p:sp>
-        <p:nvSpPr>
-          <p:cNvPr id="15" name="Text 13"/>
-          <p:cNvSpPr/>
-          <p:nvPr/>
-        </p:nvSpPr>
-        <p:spPr>
-          <a:xfrm>
-            <a:off x="6583680" y="1965960"/>
-            <a:ext cx="1097280" cy="274320"/>
-          </a:xfrm>
-          <a:prstGeom prst="rect">
-            <a:avLst/>
-          </a:prstGeom>
-          <a:noFill/>
-          <a:ln/>
-        </p:spPr>
-        <p:txBody>
-          <a:bodyPr wrap="square" lIns="0" tIns="0" rIns="0" bIns="0" rtlCol="0" anchor="ctr"/>
-          <a:lstStyle/>
-          <a:p>
-            <a:pPr algn="ctr" indent="0" marL="0">
-              <a:buNone/>
-            </a:pPr>
-            <a:r>
-              <a:rPr lang="en-US" sz="1000" dirty="0">
-                <a:solidFill>
-                  <a:srgbClr val="444444"/>
-                </a:solidFill>
-                <a:latin typeface="Calibri" pitchFamily="34" charset="0"/>
-                <a:ea typeface="Calibri" pitchFamily="34" charset="-122"/>
-                <a:cs typeface="Calibri" pitchFamily="34" charset="-120"/>
-              </a:rPr>
-              <a:t>your eye</a:t>
-            </a:r>
-            <a:endParaRPr lang="en-US" sz="1000" dirty="0"/>
-          </a:p>
-        </p:txBody>
-      </p:sp>
-      <p:sp>
-        <p:nvSpPr>
-          <p:cNvPr id="16" name="Shape 14"/>
-          <p:cNvSpPr/>
-          <p:nvPr/>
-        </p:nvSpPr>
-        <p:spPr>
-          <a:xfrm>
-            <a:off x="457200" y="3931920"/>
-            <a:ext cx="8229600" cy="868680"/>
-          </a:xfrm>
-          <a:prstGeom prst="rect">
-            <a:avLst/>
-          </a:prstGeom>
-          <a:solidFill>
-            <a:srgbClr val="0D3B6E"/>
-          </a:solidFill>
-          <a:ln w="12700">
-            <a:solidFill>
-              <a:srgbClr val="0D3B6E"/>
-            </a:solidFill>
-            <a:prstDash val="solid"/>
-          </a:ln>
-        </p:spPr>
-      </p:sp>
-      <p:sp>
-        <p:nvSpPr>
-          <p:cNvPr id="17" name="Text 15"/>
-          <p:cNvSpPr/>
-          <p:nvPr/>
-        </p:nvSpPr>
-        <p:spPr>
-          <a:xfrm>
-            <a:off x="594360" y="3977640"/>
-            <a:ext cx="7955280" cy="777240"/>
-          </a:xfrm>
-          <a:prstGeom prst="rect">
-            <a:avLst/>
-          </a:prstGeom>
-          <a:noFill/>
-          <a:ln/>
-        </p:spPr>
-        <p:txBody>
-          <a:bodyPr wrap="square" lIns="0" tIns="0" rIns="0" bIns="0" rtlCol="0" anchor="ctr"/>
-          <a:lstStyle/>
-          <a:p>
-            <a:pPr indent="0" marL="0">
-              <a:buNone/>
-            </a:pPr>
-            <a:r>
-              <a:rPr lang="en-US" sz="1400" dirty="0">
-                <a:solidFill>
-                  <a:srgbClr val="FFFFFF"/>
-                </a:solidFill>
-                <a:latin typeface="Calibri" pitchFamily="34" charset="0"/>
-                <a:ea typeface="Calibri" pitchFamily="34" charset="-122"/>
-                <a:cs typeface="Calibri" pitchFamily="34" charset="-120"/>
-              </a:rPr>
-              <a:t>Blue light (short wavelength) bounces off molecules in all directions → your eyes see blue everywhere you look up.</a:t>
-            </a:r>
-            <a:endParaRPr lang="en-US" sz="1400" dirty="0"/>
-          </a:p>
-        </p:txBody>
-      </p:sp>
-    </p:spTree>
-  </p:cSld>
-  <p:clrMapOvr>
-    <a:masterClrMapping/>
-  </p:clrMapOvr>
-</p:sld>
-</file>
-
-<file path=ppt/slides/slide4.xml><?xml version="1.0" encoding="utf-8"?>
-<p:sld xmlns:a="http://schemas.openxmlformats.org/drawingml/2006/main" xmlns:r="http://schemas.openxmlformats.org/officeDocument/2006/relationships" xmlns:p="http://schemas.openxmlformats.org/presentationml/2006/main">
-  <p:cSld name="Slide 4">
     <p:bg>
       <p:bgPr>
         <a:solidFill>

</xml_diff>